<commit_message>
Refonte esthétique du diaporama (v2)
- apercu-diaporama.html : nouveau design plus soigné — police serif
  Fraunces embarquée, icônes fines, tuiles de chiffres-clés, matrice
  d'échantillonnage 3x3, visuel 8/8, séparateurs et palette raffinés
  (bleu nuit + ambré, papier chaud). Toutes les diapos vérifiées (aucun
  débordement).
- Soutenance_MFE_LOUSTALET_Maxime.pptx : palette et titres serif
  harmonisés avec la version web.
- build_html_v2.py + fonts.json : générateur du diaporama HTML.

Co-Authored-By: Claude Opus 4.8 <noreply@anthropic.com>
Claude-Session: https://claude.ai/code/session_01B5VNFubZCPwHFVgGiYV1ZQ
</commit_message>
<xml_diff>
--- a/Soutenance_MFE_LOUSTALET_Maxime.pptx
+++ b/Soutenance_MFE_LOUSTALET_Maxime.pptx
@@ -5279,7 +5279,7 @@
             <a:avLst/>
           </a:prstGeom>
           <a:solidFill>
-            <a:srgbClr val="0E2A47"/>
+            <a:srgbClr val="0B2A4A"/>
           </a:solidFill>
           <a:ln>
             <a:noFill/>
@@ -5323,7 +5323,7 @@
             <a:avLst/>
           </a:prstGeom>
           <a:solidFill>
-            <a:srgbClr val="E4A11B"/>
+            <a:srgbClr val="E6A339"/>
           </a:solidFill>
           <a:ln>
             <a:noFill/>
@@ -5367,7 +5367,7 @@
             <a:avLst/>
           </a:prstGeom>
           <a:solidFill>
-            <a:srgbClr val="163A5F"/>
+            <a:srgbClr val="123A61"/>
           </a:solidFill>
           <a:ln>
             <a:noFill/>
@@ -5411,7 +5411,7 @@
             <a:avLst/>
           </a:prstGeom>
           <a:solidFill>
-            <a:srgbClr val="E4A11B"/>
+            <a:srgbClr val="E6A339"/>
           </a:solidFill>
           <a:ln>
             <a:noFill/>
@@ -5455,7 +5455,7 @@
             <a:avLst/>
           </a:prstGeom>
           <a:solidFill>
-            <a:srgbClr val="2E6E9E"/>
+            <a:srgbClr val="3D6A8E"/>
           </a:solidFill>
           <a:ln>
             <a:noFill/>
@@ -5520,9 +5520,9 @@
             <a:r>
               <a:rPr sz="1350" b="1" i="0">
                 <a:solidFill>
-                  <a:srgbClr val="E4A11B"/>
-                </a:solidFill>
-                <a:latin typeface="Calibri"/>
+                  <a:srgbClr val="E6A339"/>
+                </a:solidFill>
+                <a:latin typeface="Georgia"/>
               </a:rPr>
               <a:t>SOUTENANCE DE MÉMOIRE DE FIN D'ÉTUDES  ·  MASTER 2</a:t>
             </a:r>
@@ -5567,7 +5567,7 @@
                 <a:solidFill>
                   <a:srgbClr val="FFFFFF"/>
                 </a:solidFill>
-                <a:latin typeface="Calibri"/>
+                <a:latin typeface="Georgia"/>
               </a:rPr>
               <a:t>L'intégration de l'intelligence</a:t>
             </a:r>
@@ -5589,7 +5589,7 @@
                 <a:solidFill>
                   <a:srgbClr val="FFFFFF"/>
                 </a:solidFill>
-                <a:latin typeface="Calibri"/>
+                <a:latin typeface="Georgia"/>
               </a:rPr>
               <a:t>artificielle dans les PME</a:t>
             </a:r>
@@ -5634,7 +5634,7 @@
                 <a:solidFill>
                   <a:srgbClr val="CFDAE8"/>
                 </a:solidFill>
-                <a:latin typeface="Calibri"/>
+                <a:latin typeface="Georgia"/>
               </a:rPr>
               <a:t>Entre opportunités perçues et freins organisationnels</a:t>
             </a:r>
@@ -5768,7 +5768,7 @@
             <a:avLst/>
           </a:prstGeom>
           <a:solidFill>
-            <a:srgbClr val="0E2A47"/>
+            <a:srgbClr val="0B2A4A"/>
           </a:solidFill>
           <a:ln>
             <a:noFill/>
@@ -5812,7 +5812,7 @@
             <a:avLst/>
           </a:prstGeom>
           <a:solidFill>
-            <a:srgbClr val="E4A11B"/>
+            <a:srgbClr val="E6A339"/>
           </a:solidFill>
           <a:ln>
             <a:noFill/>
@@ -5856,7 +5856,7 @@
             <a:avLst/>
           </a:prstGeom>
           <a:solidFill>
-            <a:srgbClr val="E4A11B"/>
+            <a:srgbClr val="E6A339"/>
           </a:solidFill>
           <a:ln>
             <a:noFill/>
@@ -5923,7 +5923,7 @@
                 <a:solidFill>
                   <a:srgbClr val="24466B"/>
                 </a:solidFill>
-                <a:latin typeface="Calibri"/>
+                <a:latin typeface="Georgia"/>
               </a:rPr>
               <a:t>03</a:t>
             </a:r>
@@ -5968,7 +5968,7 @@
                 <a:solidFill>
                   <a:srgbClr val="FFFFFF"/>
                 </a:solidFill>
-                <a:latin typeface="Calibri"/>
+                <a:latin typeface="Georgia"/>
               </a:rPr>
               <a:t>Méthodologie empirique</a:t>
             </a:r>
@@ -6143,7 +6143,7 @@
             <a:avLst/>
           </a:prstGeom>
           <a:solidFill>
-            <a:srgbClr val="FFFFFF"/>
+            <a:srgbClr val="FCFBF8"/>
           </a:solidFill>
           <a:ln>
             <a:noFill/>
@@ -6187,7 +6187,7 @@
             <a:avLst/>
           </a:prstGeom>
           <a:solidFill>
-            <a:srgbClr val="FFFFFF"/>
+            <a:srgbClr val="FCFBF8"/>
           </a:solidFill>
           <a:ln>
             <a:noFill/>
@@ -6231,7 +6231,7 @@
             <a:avLst/>
           </a:prstGeom>
           <a:solidFill>
-            <a:srgbClr val="E4A11B"/>
+            <a:srgbClr val="E6A339"/>
           </a:solidFill>
           <a:ln>
             <a:noFill/>
@@ -6294,9 +6294,9 @@
               </a:spcAft>
             </a:pPr>
             <a:r>
-              <a:rPr sz="1250" b="1" i="0">
-                <a:solidFill>
-                  <a:srgbClr val="2E6E9E"/>
+              <a:rPr sz="1200" b="1" i="0">
+                <a:solidFill>
+                  <a:srgbClr val="3D6A8E"/>
                 </a:solidFill>
                 <a:latin typeface="Calibri"/>
               </a:rPr>
@@ -6341,9 +6341,9 @@
             <a:r>
               <a:rPr sz="2700" b="1" i="0">
                 <a:solidFill>
-                  <a:srgbClr val="0E2A47"/>
-                </a:solidFill>
-                <a:latin typeface="Calibri"/>
+                  <a:srgbClr val="0B2A4A"/>
+                </a:solidFill>
+                <a:latin typeface="Georgia"/>
               </a:rPr>
               <a:t>Une étude qualitative exploratoire assumée</a:t>
             </a:r>
@@ -6365,7 +6365,7 @@
             <a:avLst/>
           </a:prstGeom>
           <a:solidFill>
-            <a:srgbClr val="E4A11B"/>
+            <a:srgbClr val="E6A339"/>
           </a:solidFill>
           <a:ln>
             <a:noFill/>
@@ -6415,7 +6415,7 @@
           </a:solidFill>
           <a:ln w="12700">
             <a:solidFill>
-              <a:srgbClr val="D7DDE6"/>
+              <a:srgbClr val="E6DFD3"/>
             </a:solidFill>
           </a:ln>
           <a:effectLst/>
@@ -6457,7 +6457,7 @@
             <a:avLst/>
           </a:prstGeom>
           <a:solidFill>
-            <a:srgbClr val="2E6E9E"/>
+            <a:srgbClr val="3D6A8E"/>
           </a:solidFill>
           <a:ln>
             <a:noFill/>
@@ -6522,9 +6522,9 @@
             <a:r>
               <a:rPr sz="1300" b="1" i="0">
                 <a:solidFill>
-                  <a:srgbClr val="2E6E9E"/>
-                </a:solidFill>
-                <a:latin typeface="Calibri"/>
+                  <a:srgbClr val="3D6A8E"/>
+                </a:solidFill>
+                <a:latin typeface="Georgia"/>
               </a:rPr>
               <a:t>POURQUOI LE QUALITATIF ?</a:t>
             </a:r>
@@ -6567,7 +6567,7 @@
             <a:r>
               <a:rPr sz="1350" b="1">
                 <a:solidFill>
-                  <a:srgbClr val="E4A11B"/>
+                  <a:srgbClr val="E6A339"/>
                 </a:solidFill>
                 <a:latin typeface="Calibri"/>
               </a:rPr>
@@ -6576,7 +6576,7 @@
             <a:r>
               <a:rPr sz="1350" b="1">
                 <a:solidFill>
-                  <a:srgbClr val="1A2033"/>
+                  <a:srgbClr val="18243C"/>
                 </a:solidFill>
                 <a:latin typeface="Calibri"/>
               </a:rPr>
@@ -6585,7 +6585,7 @@
             <a:r>
               <a:rPr sz="1350" b="0">
                 <a:solidFill>
-                  <a:srgbClr val="55607A"/>
+                  <a:srgbClr val="54607A"/>
                 </a:solidFill>
                 <a:latin typeface="Calibri"/>
               </a:rPr>
@@ -6607,7 +6607,7 @@
             <a:r>
               <a:rPr sz="1350" b="1">
                 <a:solidFill>
-                  <a:srgbClr val="E4A11B"/>
+                  <a:srgbClr val="E6A339"/>
                 </a:solidFill>
                 <a:latin typeface="Calibri"/>
               </a:rPr>
@@ -6616,7 +6616,7 @@
             <a:r>
               <a:rPr sz="1350" b="1">
                 <a:solidFill>
-                  <a:srgbClr val="1A2033"/>
+                  <a:srgbClr val="18243C"/>
                 </a:solidFill>
                 <a:latin typeface="Calibri"/>
               </a:rPr>
@@ -6625,7 +6625,7 @@
             <a:r>
               <a:rPr sz="1350" b="0">
                 <a:solidFill>
-                  <a:srgbClr val="55607A"/>
+                  <a:srgbClr val="54607A"/>
                 </a:solidFill>
                 <a:latin typeface="Calibri"/>
               </a:rPr>
@@ -6647,7 +6647,7 @@
             <a:r>
               <a:rPr sz="1350" b="1">
                 <a:solidFill>
-                  <a:srgbClr val="E4A11B"/>
+                  <a:srgbClr val="E6A339"/>
                 </a:solidFill>
                 <a:latin typeface="Calibri"/>
               </a:rPr>
@@ -6656,7 +6656,7 @@
             <a:r>
               <a:rPr sz="1350" b="1">
                 <a:solidFill>
-                  <a:srgbClr val="1A2033"/>
+                  <a:srgbClr val="18243C"/>
                 </a:solidFill>
                 <a:latin typeface="Calibri"/>
               </a:rPr>
@@ -6665,7 +6665,7 @@
             <a:r>
               <a:rPr sz="1350" b="0">
                 <a:solidFill>
-                  <a:srgbClr val="55607A"/>
+                  <a:srgbClr val="54607A"/>
                 </a:solidFill>
                 <a:latin typeface="Calibri"/>
               </a:rPr>
@@ -6687,7 +6687,7 @@
             <a:r>
               <a:rPr sz="1350" b="1">
                 <a:solidFill>
-                  <a:srgbClr val="E4A11B"/>
+                  <a:srgbClr val="E6A339"/>
                 </a:solidFill>
                 <a:latin typeface="Calibri"/>
               </a:rPr>
@@ -6696,7 +6696,7 @@
             <a:r>
               <a:rPr sz="1350" b="1">
                 <a:solidFill>
-                  <a:srgbClr val="1A2033"/>
+                  <a:srgbClr val="18243C"/>
                 </a:solidFill>
                 <a:latin typeface="Calibri"/>
               </a:rPr>
@@ -6705,7 +6705,7 @@
             <a:r>
               <a:rPr sz="1350" b="0">
                 <a:solidFill>
-                  <a:srgbClr val="55607A"/>
+                  <a:srgbClr val="54607A"/>
                 </a:solidFill>
                 <a:latin typeface="Calibri"/>
               </a:rPr>
@@ -6735,7 +6735,7 @@
           </a:solidFill>
           <a:ln w="12700">
             <a:solidFill>
-              <a:srgbClr val="D7DDE6"/>
+              <a:srgbClr val="E6DFD3"/>
             </a:solidFill>
           </a:ln>
           <a:effectLst/>
@@ -6777,7 +6777,7 @@
             <a:avLst/>
           </a:prstGeom>
           <a:solidFill>
-            <a:srgbClr val="E4A11B"/>
+            <a:srgbClr val="E6A339"/>
           </a:solidFill>
           <a:ln>
             <a:noFill/>
@@ -6842,9 +6842,9 @@
             <a:r>
               <a:rPr sz="1300" b="1" i="0">
                 <a:solidFill>
-                  <a:srgbClr val="C6860E"/>
-                </a:solidFill>
-                <a:latin typeface="Calibri"/>
+                  <a:srgbClr val="AF7112"/>
+                </a:solidFill>
+                <a:latin typeface="Georgia"/>
               </a:rPr>
               <a:t>UN ÉCHANTILLONNAGE RAISONNÉ</a:t>
             </a:r>
@@ -6887,9 +6887,9 @@
             <a:r>
               <a:rPr sz="1350" b="1" i="0">
                 <a:solidFill>
-                  <a:srgbClr val="0E2A47"/>
-                </a:solidFill>
-                <a:latin typeface="Calibri"/>
+                  <a:srgbClr val="0B2A4A"/>
+                </a:solidFill>
+                <a:latin typeface="Georgia"/>
               </a:rPr>
               <a:t>3 familles de profils</a:t>
             </a:r>
@@ -6911,7 +6911,7 @@
             <a:avLst/>
           </a:prstGeom>
           <a:solidFill>
-            <a:srgbClr val="E4A11B"/>
+            <a:srgbClr val="E6A339"/>
           </a:solidFill>
           <a:ln>
             <a:noFill/>
@@ -6976,7 +6976,7 @@
             <a:r>
               <a:rPr sz="1200" b="0" i="0">
                 <a:solidFill>
-                  <a:srgbClr val="55607A"/>
+                  <a:srgbClr val="54607A"/>
                 </a:solidFill>
                 <a:latin typeface="Calibri"/>
               </a:rPr>
@@ -7000,7 +7000,7 @@
             <a:avLst/>
           </a:prstGeom>
           <a:solidFill>
-            <a:srgbClr val="E4A11B"/>
+            <a:srgbClr val="E6A339"/>
           </a:solidFill>
           <a:ln>
             <a:noFill/>
@@ -7065,7 +7065,7 @@
             <a:r>
               <a:rPr sz="1200" b="0" i="0">
                 <a:solidFill>
-                  <a:srgbClr val="55607A"/>
+                  <a:srgbClr val="54607A"/>
                 </a:solidFill>
                 <a:latin typeface="Calibri"/>
               </a:rPr>
@@ -7089,7 +7089,7 @@
             <a:avLst/>
           </a:prstGeom>
           <a:solidFill>
-            <a:srgbClr val="E4A11B"/>
+            <a:srgbClr val="E6A339"/>
           </a:solidFill>
           <a:ln>
             <a:noFill/>
@@ -7154,7 +7154,7 @@
             <a:r>
               <a:rPr sz="1200" b="0" i="0">
                 <a:solidFill>
-                  <a:srgbClr val="55607A"/>
+                  <a:srgbClr val="54607A"/>
                 </a:solidFill>
                 <a:latin typeface="Calibri"/>
               </a:rPr>
@@ -7199,9 +7199,9 @@
             <a:r>
               <a:rPr sz="1350" b="1" i="0">
                 <a:solidFill>
-                  <a:srgbClr val="0E2A47"/>
-                </a:solidFill>
-                <a:latin typeface="Calibri"/>
+                  <a:srgbClr val="0B2A4A"/>
+                </a:solidFill>
+                <a:latin typeface="Georgia"/>
               </a:rPr>
               <a:t>3 tranches d'âge</a:t>
             </a:r>
@@ -7223,7 +7223,7 @@
             <a:avLst/>
           </a:prstGeom>
           <a:solidFill>
-            <a:srgbClr val="2E6E9E"/>
+            <a:srgbClr val="3D6A8E"/>
           </a:solidFill>
           <a:ln>
             <a:noFill/>
@@ -7288,7 +7288,7 @@
             <a:r>
               <a:rPr sz="1200" b="0" i="0">
                 <a:solidFill>
-                  <a:srgbClr val="55607A"/>
+                  <a:srgbClr val="54607A"/>
                 </a:solidFill>
                 <a:latin typeface="Calibri"/>
               </a:rPr>
@@ -7312,7 +7312,7 @@
             <a:avLst/>
           </a:prstGeom>
           <a:solidFill>
-            <a:srgbClr val="2E6E9E"/>
+            <a:srgbClr val="3D6A8E"/>
           </a:solidFill>
           <a:ln>
             <a:noFill/>
@@ -7377,7 +7377,7 @@
             <a:r>
               <a:rPr sz="1200" b="0" i="0">
                 <a:solidFill>
-                  <a:srgbClr val="55607A"/>
+                  <a:srgbClr val="54607A"/>
                 </a:solidFill>
                 <a:latin typeface="Calibri"/>
               </a:rPr>
@@ -7401,7 +7401,7 @@
             <a:avLst/>
           </a:prstGeom>
           <a:solidFill>
-            <a:srgbClr val="2E6E9E"/>
+            <a:srgbClr val="3D6A8E"/>
           </a:solidFill>
           <a:ln>
             <a:noFill/>
@@ -7466,7 +7466,7 @@
             <a:r>
               <a:rPr sz="1200" b="0" i="0">
                 <a:solidFill>
-                  <a:srgbClr val="55607A"/>
+                  <a:srgbClr val="54607A"/>
                 </a:solidFill>
                 <a:latin typeface="Calibri"/>
               </a:rPr>
@@ -7490,7 +7490,7 @@
             <a:avLst/>
           </a:prstGeom>
           <a:solidFill>
-            <a:srgbClr val="D7DDE6"/>
+            <a:srgbClr val="E6DFD3"/>
           </a:solidFill>
           <a:ln>
             <a:noFill/>
@@ -7642,7 +7642,7 @@
             <a:avLst/>
           </a:prstGeom>
           <a:solidFill>
-            <a:srgbClr val="0E2A47"/>
+            <a:srgbClr val="0B2A4A"/>
           </a:solidFill>
           <a:ln>
             <a:noFill/>
@@ -7686,7 +7686,7 @@
             <a:avLst/>
           </a:prstGeom>
           <a:solidFill>
-            <a:srgbClr val="E4A11B"/>
+            <a:srgbClr val="E6A339"/>
           </a:solidFill>
           <a:ln>
             <a:noFill/>
@@ -7730,7 +7730,7 @@
             <a:avLst/>
           </a:prstGeom>
           <a:solidFill>
-            <a:srgbClr val="E4A11B"/>
+            <a:srgbClr val="E6A339"/>
           </a:solidFill>
           <a:ln>
             <a:noFill/>
@@ -7797,7 +7797,7 @@
                 <a:solidFill>
                   <a:srgbClr val="24466B"/>
                 </a:solidFill>
-                <a:latin typeface="Calibri"/>
+                <a:latin typeface="Georgia"/>
               </a:rPr>
               <a:t>04</a:t>
             </a:r>
@@ -7842,7 +7842,7 @@
                 <a:solidFill>
                   <a:srgbClr val="FFFFFF"/>
                 </a:solidFill>
-                <a:latin typeface="Calibri"/>
+                <a:latin typeface="Georgia"/>
               </a:rPr>
               <a:t>Résultats &amp; analyse</a:t>
             </a:r>
@@ -8017,7 +8017,7 @@
             <a:avLst/>
           </a:prstGeom>
           <a:solidFill>
-            <a:srgbClr val="FFFFFF"/>
+            <a:srgbClr val="FCFBF8"/>
           </a:solidFill>
           <a:ln>
             <a:noFill/>
@@ -8061,7 +8061,7 @@
             <a:avLst/>
           </a:prstGeom>
           <a:solidFill>
-            <a:srgbClr val="FFFFFF"/>
+            <a:srgbClr val="FCFBF8"/>
           </a:solidFill>
           <a:ln>
             <a:noFill/>
@@ -8105,7 +8105,7 @@
             <a:avLst/>
           </a:prstGeom>
           <a:solidFill>
-            <a:srgbClr val="E4A11B"/>
+            <a:srgbClr val="E6A339"/>
           </a:solidFill>
           <a:ln>
             <a:noFill/>
@@ -8168,9 +8168,9 @@
               </a:spcAft>
             </a:pPr>
             <a:r>
-              <a:rPr sz="1250" b="1" i="0">
-                <a:solidFill>
-                  <a:srgbClr val="2E6E9E"/>
+              <a:rPr sz="1200" b="1" i="0">
+                <a:solidFill>
+                  <a:srgbClr val="3D6A8E"/>
                 </a:solidFill>
                 <a:latin typeface="Calibri"/>
               </a:rPr>
@@ -8215,9 +8215,9 @@
             <a:r>
               <a:rPr sz="2700" b="1" i="0">
                 <a:solidFill>
-                  <a:srgbClr val="0E2A47"/>
-                </a:solidFill>
-                <a:latin typeface="Calibri"/>
+                  <a:srgbClr val="0B2A4A"/>
+                </a:solidFill>
+                <a:latin typeface="Georgia"/>
               </a:rPr>
               <a:t>Comment les salariés perçoivent-ils l'IA ?</a:t>
             </a:r>
@@ -8239,7 +8239,7 @@
             <a:avLst/>
           </a:prstGeom>
           <a:solidFill>
-            <a:srgbClr val="E4A11B"/>
+            <a:srgbClr val="E6A339"/>
           </a:solidFill>
           <a:ln>
             <a:noFill/>
@@ -8285,7 +8285,7 @@
             </a:avLst>
           </a:prstGeom>
           <a:solidFill>
-            <a:srgbClr val="0E2A47"/>
+            <a:srgbClr val="0B2A4A"/>
           </a:solidFill>
           <a:ln>
             <a:noFill/>
@@ -8329,7 +8329,7 @@
             <a:avLst/>
           </a:prstGeom>
           <a:solidFill>
-            <a:srgbClr val="E4A11B"/>
+            <a:srgbClr val="E6A339"/>
           </a:solidFill>
           <a:ln>
             <a:noFill/>
@@ -8394,9 +8394,9 @@
             <a:r>
               <a:rPr sz="1450" b="1" i="0">
                 <a:solidFill>
-                  <a:srgbClr val="E4A11B"/>
-                </a:solidFill>
-                <a:latin typeface="Calibri"/>
+                  <a:srgbClr val="E6A339"/>
+                </a:solidFill>
+                <a:latin typeface="Georgia"/>
               </a:rPr>
               <a:t>Résultat clé — </a:t>
             </a:r>
@@ -8448,7 +8448,7 @@
             <a:r>
               <a:rPr sz="1380" b="1">
                 <a:solidFill>
-                  <a:srgbClr val="E4A11B"/>
+                  <a:srgbClr val="E6A339"/>
                 </a:solidFill>
                 <a:latin typeface="Calibri"/>
               </a:rPr>
@@ -8457,7 +8457,7 @@
             <a:r>
               <a:rPr sz="1380" b="1">
                 <a:solidFill>
-                  <a:srgbClr val="1A2033"/>
+                  <a:srgbClr val="18243C"/>
                 </a:solidFill>
                 <a:latin typeface="Calibri"/>
               </a:rPr>
@@ -8466,7 +8466,7 @@
             <a:r>
               <a:rPr sz="1380" b="0">
                 <a:solidFill>
-                  <a:srgbClr val="55607A"/>
+                  <a:srgbClr val="54607A"/>
                 </a:solidFill>
                 <a:latin typeface="Calibri"/>
               </a:rPr>
@@ -8488,7 +8488,7 @@
             <a:r>
               <a:rPr sz="1380" b="1">
                 <a:solidFill>
-                  <a:srgbClr val="E4A11B"/>
+                  <a:srgbClr val="E6A339"/>
                 </a:solidFill>
                 <a:latin typeface="Calibri"/>
               </a:rPr>
@@ -8497,7 +8497,7 @@
             <a:r>
               <a:rPr sz="1380" b="1">
                 <a:solidFill>
-                  <a:srgbClr val="1A2033"/>
+                  <a:srgbClr val="18243C"/>
                 </a:solidFill>
                 <a:latin typeface="Calibri"/>
               </a:rPr>
@@ -8506,7 +8506,7 @@
             <a:r>
               <a:rPr sz="1380" b="0">
                 <a:solidFill>
-                  <a:srgbClr val="55607A"/>
+                  <a:srgbClr val="54607A"/>
                 </a:solidFill>
                 <a:latin typeface="Calibri"/>
               </a:rPr>
@@ -8528,7 +8528,7 @@
             <a:r>
               <a:rPr sz="1380" b="1">
                 <a:solidFill>
-                  <a:srgbClr val="E4A11B"/>
+                  <a:srgbClr val="E6A339"/>
                 </a:solidFill>
                 <a:latin typeface="Calibri"/>
               </a:rPr>
@@ -8537,7 +8537,7 @@
             <a:r>
               <a:rPr sz="1380" b="1">
                 <a:solidFill>
-                  <a:srgbClr val="1A2033"/>
+                  <a:srgbClr val="18243C"/>
                 </a:solidFill>
                 <a:latin typeface="Calibri"/>
               </a:rPr>
@@ -8546,7 +8546,7 @@
             <a:r>
               <a:rPr sz="1380" b="0">
                 <a:solidFill>
-                  <a:srgbClr val="55607A"/>
+                  <a:srgbClr val="54607A"/>
                 </a:solidFill>
                 <a:latin typeface="Calibri"/>
               </a:rPr>
@@ -8568,7 +8568,7 @@
             <a:r>
               <a:rPr sz="1380" b="1">
                 <a:solidFill>
-                  <a:srgbClr val="E4A11B"/>
+                  <a:srgbClr val="E6A339"/>
                 </a:solidFill>
                 <a:latin typeface="Calibri"/>
               </a:rPr>
@@ -8577,7 +8577,7 @@
             <a:r>
               <a:rPr sz="1380" b="1">
                 <a:solidFill>
-                  <a:srgbClr val="1A2033"/>
+                  <a:srgbClr val="18243C"/>
                 </a:solidFill>
                 <a:latin typeface="Calibri"/>
               </a:rPr>
@@ -8586,7 +8586,7 @@
             <a:r>
               <a:rPr sz="1380" b="0">
                 <a:solidFill>
-                  <a:srgbClr val="55607A"/>
+                  <a:srgbClr val="54607A"/>
                 </a:solidFill>
                 <a:latin typeface="Calibri"/>
               </a:rPr>
@@ -8608,7 +8608,7 @@
             <a:r>
               <a:rPr sz="1380" b="1">
                 <a:solidFill>
-                  <a:srgbClr val="E4A11B"/>
+                  <a:srgbClr val="E6A339"/>
                 </a:solidFill>
                 <a:latin typeface="Calibri"/>
               </a:rPr>
@@ -8617,7 +8617,7 @@
             <a:r>
               <a:rPr sz="1380" b="1">
                 <a:solidFill>
-                  <a:srgbClr val="1A2033"/>
+                  <a:srgbClr val="18243C"/>
                 </a:solidFill>
                 <a:latin typeface="Calibri"/>
               </a:rPr>
@@ -8626,7 +8626,7 @@
             <a:r>
               <a:rPr sz="1380" b="0">
                 <a:solidFill>
-                  <a:srgbClr val="55607A"/>
+                  <a:srgbClr val="54607A"/>
                 </a:solidFill>
                 <a:latin typeface="Calibri"/>
               </a:rPr>
@@ -8650,7 +8650,7 @@
             <a:avLst/>
           </a:prstGeom>
           <a:solidFill>
-            <a:srgbClr val="EDF1F6"/>
+            <a:srgbClr val="F7F2E8"/>
           </a:solidFill>
           <a:ln>
             <a:noFill/>
@@ -8694,7 +8694,7 @@
             <a:avLst/>
           </a:prstGeom>
           <a:solidFill>
-            <a:srgbClr val="2E6E9E"/>
+            <a:srgbClr val="3D6A8E"/>
           </a:solidFill>
           <a:ln>
             <a:noFill/>
@@ -8759,16 +8759,16 @@
             <a:r>
               <a:rPr sz="1250" b="1" i="0">
                 <a:solidFill>
-                  <a:srgbClr val="2E6E9E"/>
-                </a:solidFill>
-                <a:latin typeface="Calibri"/>
+                  <a:srgbClr val="3D6A8E"/>
+                </a:solidFill>
+                <a:latin typeface="Georgia"/>
               </a:rPr>
               <a:t>Lien littérature — </a:t>
             </a:r>
             <a:r>
               <a:rPr sz="1250" b="0" i="1">
                 <a:solidFill>
-                  <a:srgbClr val="1A2033"/>
+                  <a:srgbClr val="18243C"/>
                 </a:solidFill>
                 <a:latin typeface="Calibri"/>
               </a:rPr>
@@ -8900,7 +8900,7 @@
             <a:avLst/>
           </a:prstGeom>
           <a:solidFill>
-            <a:srgbClr val="FFFFFF"/>
+            <a:srgbClr val="FCFBF8"/>
           </a:solidFill>
           <a:ln>
             <a:noFill/>
@@ -8944,7 +8944,7 @@
             <a:avLst/>
           </a:prstGeom>
           <a:solidFill>
-            <a:srgbClr val="FFFFFF"/>
+            <a:srgbClr val="FCFBF8"/>
           </a:solidFill>
           <a:ln>
             <a:noFill/>
@@ -8988,7 +8988,7 @@
             <a:avLst/>
           </a:prstGeom>
           <a:solidFill>
-            <a:srgbClr val="E4A11B"/>
+            <a:srgbClr val="E6A339"/>
           </a:solidFill>
           <a:ln>
             <a:noFill/>
@@ -9051,9 +9051,9 @@
               </a:spcAft>
             </a:pPr>
             <a:r>
-              <a:rPr sz="1250" b="1" i="0">
-                <a:solidFill>
-                  <a:srgbClr val="2E6E9E"/>
+              <a:rPr sz="1200" b="1" i="0">
+                <a:solidFill>
+                  <a:srgbClr val="3D6A8E"/>
                 </a:solidFill>
                 <a:latin typeface="Calibri"/>
               </a:rPr>
@@ -9098,9 +9098,9 @@
             <a:r>
               <a:rPr sz="2700" b="1" i="0">
                 <a:solidFill>
-                  <a:srgbClr val="0E2A47"/>
-                </a:solidFill>
-                <a:latin typeface="Calibri"/>
+                  <a:srgbClr val="0B2A4A"/>
+                </a:solidFill>
+                <a:latin typeface="Georgia"/>
               </a:rPr>
               <a:t>Quels sont les freins à l'adoption de l'IA ?</a:t>
             </a:r>
@@ -9122,7 +9122,7 @@
             <a:avLst/>
           </a:prstGeom>
           <a:solidFill>
-            <a:srgbClr val="E4A11B"/>
+            <a:srgbClr val="E6A339"/>
           </a:solidFill>
           <a:ln>
             <a:noFill/>
@@ -9168,7 +9168,7 @@
             </a:avLst>
           </a:prstGeom>
           <a:solidFill>
-            <a:srgbClr val="0E2A47"/>
+            <a:srgbClr val="0B2A4A"/>
           </a:solidFill>
           <a:ln>
             <a:noFill/>
@@ -9212,7 +9212,7 @@
             <a:avLst/>
           </a:prstGeom>
           <a:solidFill>
-            <a:srgbClr val="E4A11B"/>
+            <a:srgbClr val="E6A339"/>
           </a:solidFill>
           <a:ln>
             <a:noFill/>
@@ -9277,9 +9277,9 @@
             <a:r>
               <a:rPr sz="1450" b="1" i="0">
                 <a:solidFill>
-                  <a:srgbClr val="E4A11B"/>
-                </a:solidFill>
-                <a:latin typeface="Calibri"/>
+                  <a:srgbClr val="E6A339"/>
+                </a:solidFill>
+                <a:latin typeface="Georgia"/>
               </a:rPr>
               <a:t>Résultat clé — </a:t>
             </a:r>
@@ -9331,7 +9331,7 @@
             <a:r>
               <a:rPr sz="1380" b="1">
                 <a:solidFill>
-                  <a:srgbClr val="E4A11B"/>
+                  <a:srgbClr val="E6A339"/>
                 </a:solidFill>
                 <a:latin typeface="Calibri"/>
               </a:rPr>
@@ -9340,7 +9340,7 @@
             <a:r>
               <a:rPr sz="1380" b="1">
                 <a:solidFill>
-                  <a:srgbClr val="1A2033"/>
+                  <a:srgbClr val="18243C"/>
                 </a:solidFill>
                 <a:latin typeface="Calibri"/>
               </a:rPr>
@@ -9349,7 +9349,7 @@
             <a:r>
               <a:rPr sz="1380" b="0">
                 <a:solidFill>
-                  <a:srgbClr val="55607A"/>
+                  <a:srgbClr val="54607A"/>
                 </a:solidFill>
                 <a:latin typeface="Calibri"/>
               </a:rPr>
@@ -9371,7 +9371,7 @@
             <a:r>
               <a:rPr sz="1380" b="1">
                 <a:solidFill>
-                  <a:srgbClr val="E4A11B"/>
+                  <a:srgbClr val="E6A339"/>
                 </a:solidFill>
                 <a:latin typeface="Calibri"/>
               </a:rPr>
@@ -9380,7 +9380,7 @@
             <a:r>
               <a:rPr sz="1380" b="1">
                 <a:solidFill>
-                  <a:srgbClr val="1A2033"/>
+                  <a:srgbClr val="18243C"/>
                 </a:solidFill>
                 <a:latin typeface="Calibri"/>
               </a:rPr>
@@ -9389,7 +9389,7 @@
             <a:r>
               <a:rPr sz="1380" b="0">
                 <a:solidFill>
-                  <a:srgbClr val="55607A"/>
+                  <a:srgbClr val="54607A"/>
                 </a:solidFill>
                 <a:latin typeface="Calibri"/>
               </a:rPr>
@@ -9411,7 +9411,7 @@
             <a:r>
               <a:rPr sz="1380" b="1">
                 <a:solidFill>
-                  <a:srgbClr val="E4A11B"/>
+                  <a:srgbClr val="E6A339"/>
                 </a:solidFill>
                 <a:latin typeface="Calibri"/>
               </a:rPr>
@@ -9420,7 +9420,7 @@
             <a:r>
               <a:rPr sz="1380" b="1">
                 <a:solidFill>
-                  <a:srgbClr val="1A2033"/>
+                  <a:srgbClr val="18243C"/>
                 </a:solidFill>
                 <a:latin typeface="Calibri"/>
               </a:rPr>
@@ -9429,7 +9429,7 @@
             <a:r>
               <a:rPr sz="1380" b="0">
                 <a:solidFill>
-                  <a:srgbClr val="55607A"/>
+                  <a:srgbClr val="54607A"/>
                 </a:solidFill>
                 <a:latin typeface="Calibri"/>
               </a:rPr>
@@ -9451,7 +9451,7 @@
             <a:r>
               <a:rPr sz="1380" b="1">
                 <a:solidFill>
-                  <a:srgbClr val="E4A11B"/>
+                  <a:srgbClr val="E6A339"/>
                 </a:solidFill>
                 <a:latin typeface="Calibri"/>
               </a:rPr>
@@ -9460,7 +9460,7 @@
             <a:r>
               <a:rPr sz="1380" b="1">
                 <a:solidFill>
-                  <a:srgbClr val="1A2033"/>
+                  <a:srgbClr val="18243C"/>
                 </a:solidFill>
                 <a:latin typeface="Calibri"/>
               </a:rPr>
@@ -9469,7 +9469,7 @@
             <a:r>
               <a:rPr sz="1380" b="0">
                 <a:solidFill>
-                  <a:srgbClr val="55607A"/>
+                  <a:srgbClr val="54607A"/>
                 </a:solidFill>
                 <a:latin typeface="Calibri"/>
               </a:rPr>
@@ -9491,7 +9491,7 @@
             <a:r>
               <a:rPr sz="1380" b="1">
                 <a:solidFill>
-                  <a:srgbClr val="E4A11B"/>
+                  <a:srgbClr val="E6A339"/>
                 </a:solidFill>
                 <a:latin typeface="Calibri"/>
               </a:rPr>
@@ -9500,7 +9500,7 @@
             <a:r>
               <a:rPr sz="1380" b="1">
                 <a:solidFill>
-                  <a:srgbClr val="1A2033"/>
+                  <a:srgbClr val="18243C"/>
                 </a:solidFill>
                 <a:latin typeface="Calibri"/>
               </a:rPr>
@@ -9509,7 +9509,7 @@
             <a:r>
               <a:rPr sz="1380" b="0">
                 <a:solidFill>
-                  <a:srgbClr val="55607A"/>
+                  <a:srgbClr val="54607A"/>
                 </a:solidFill>
                 <a:latin typeface="Calibri"/>
               </a:rPr>
@@ -9533,7 +9533,7 @@
             <a:avLst/>
           </a:prstGeom>
           <a:solidFill>
-            <a:srgbClr val="EDF1F6"/>
+            <a:srgbClr val="F7F2E8"/>
           </a:solidFill>
           <a:ln>
             <a:noFill/>
@@ -9577,7 +9577,7 @@
             <a:avLst/>
           </a:prstGeom>
           <a:solidFill>
-            <a:srgbClr val="2E6E9E"/>
+            <a:srgbClr val="3D6A8E"/>
           </a:solidFill>
           <a:ln>
             <a:noFill/>
@@ -9642,16 +9642,16 @@
             <a:r>
               <a:rPr sz="1250" b="1" i="0">
                 <a:solidFill>
-                  <a:srgbClr val="2E6E9E"/>
-                </a:solidFill>
-                <a:latin typeface="Calibri"/>
+                  <a:srgbClr val="3D6A8E"/>
+                </a:solidFill>
+                <a:latin typeface="Georgia"/>
               </a:rPr>
               <a:t>Lien littérature — </a:t>
             </a:r>
             <a:r>
               <a:rPr sz="1250" b="0" i="1">
                 <a:solidFill>
-                  <a:srgbClr val="1A2033"/>
+                  <a:srgbClr val="18243C"/>
                 </a:solidFill>
                 <a:latin typeface="Calibri"/>
               </a:rPr>
@@ -9783,7 +9783,7 @@
             <a:avLst/>
           </a:prstGeom>
           <a:solidFill>
-            <a:srgbClr val="FFFFFF"/>
+            <a:srgbClr val="FCFBF8"/>
           </a:solidFill>
           <a:ln>
             <a:noFill/>
@@ -9827,7 +9827,7 @@
             <a:avLst/>
           </a:prstGeom>
           <a:solidFill>
-            <a:srgbClr val="FFFFFF"/>
+            <a:srgbClr val="FCFBF8"/>
           </a:solidFill>
           <a:ln>
             <a:noFill/>
@@ -9871,7 +9871,7 @@
             <a:avLst/>
           </a:prstGeom>
           <a:solidFill>
-            <a:srgbClr val="E4A11B"/>
+            <a:srgbClr val="E6A339"/>
           </a:solidFill>
           <a:ln>
             <a:noFill/>
@@ -9934,9 +9934,9 @@
               </a:spcAft>
             </a:pPr>
             <a:r>
-              <a:rPr sz="1250" b="1" i="0">
-                <a:solidFill>
-                  <a:srgbClr val="2E6E9E"/>
+              <a:rPr sz="1200" b="1" i="0">
+                <a:solidFill>
+                  <a:srgbClr val="3D6A8E"/>
                 </a:solidFill>
                 <a:latin typeface="Calibri"/>
               </a:rPr>
@@ -9981,9 +9981,9 @@
             <a:r>
               <a:rPr sz="2700" b="1" i="0">
                 <a:solidFill>
-                  <a:srgbClr val="0E2A47"/>
-                </a:solidFill>
-                <a:latin typeface="Calibri"/>
+                  <a:srgbClr val="0B2A4A"/>
+                </a:solidFill>
+                <a:latin typeface="Georgia"/>
               </a:rPr>
               <a:t>En quoi les spécificités PME influencent-elles l'adoption ?</a:t>
             </a:r>
@@ -10005,7 +10005,7 @@
             <a:avLst/>
           </a:prstGeom>
           <a:solidFill>
-            <a:srgbClr val="E4A11B"/>
+            <a:srgbClr val="E6A339"/>
           </a:solidFill>
           <a:ln>
             <a:noFill/>
@@ -10051,7 +10051,7 @@
             </a:avLst>
           </a:prstGeom>
           <a:solidFill>
-            <a:srgbClr val="0E2A47"/>
+            <a:srgbClr val="0B2A4A"/>
           </a:solidFill>
           <a:ln>
             <a:noFill/>
@@ -10095,7 +10095,7 @@
             <a:avLst/>
           </a:prstGeom>
           <a:solidFill>
-            <a:srgbClr val="E4A11B"/>
+            <a:srgbClr val="E6A339"/>
           </a:solidFill>
           <a:ln>
             <a:noFill/>
@@ -10160,9 +10160,9 @@
             <a:r>
               <a:rPr sz="1450" b="1" i="0">
                 <a:solidFill>
-                  <a:srgbClr val="E4A11B"/>
-                </a:solidFill>
-                <a:latin typeface="Calibri"/>
+                  <a:srgbClr val="E6A339"/>
+                </a:solidFill>
+                <a:latin typeface="Georgia"/>
               </a:rPr>
               <a:t>Résultat clé — </a:t>
             </a:r>
@@ -10214,7 +10214,7 @@
             <a:r>
               <a:rPr sz="1380" b="1">
                 <a:solidFill>
-                  <a:srgbClr val="E4A11B"/>
+                  <a:srgbClr val="E6A339"/>
                 </a:solidFill>
                 <a:latin typeface="Calibri"/>
               </a:rPr>
@@ -10223,7 +10223,7 @@
             <a:r>
               <a:rPr sz="1380" b="1">
                 <a:solidFill>
-                  <a:srgbClr val="1A2033"/>
+                  <a:srgbClr val="18243C"/>
                 </a:solidFill>
                 <a:latin typeface="Calibri"/>
               </a:rPr>
@@ -10232,7 +10232,7 @@
             <a:r>
               <a:rPr sz="1380" b="0">
                 <a:solidFill>
-                  <a:srgbClr val="55607A"/>
+                  <a:srgbClr val="54607A"/>
                 </a:solidFill>
                 <a:latin typeface="Calibri"/>
               </a:rPr>
@@ -10254,7 +10254,7 @@
             <a:r>
               <a:rPr sz="1380" b="1">
                 <a:solidFill>
-                  <a:srgbClr val="E4A11B"/>
+                  <a:srgbClr val="E6A339"/>
                 </a:solidFill>
                 <a:latin typeface="Calibri"/>
               </a:rPr>
@@ -10263,7 +10263,7 @@
             <a:r>
               <a:rPr sz="1380" b="1">
                 <a:solidFill>
-                  <a:srgbClr val="1A2033"/>
+                  <a:srgbClr val="18243C"/>
                 </a:solidFill>
                 <a:latin typeface="Calibri"/>
               </a:rPr>
@@ -10272,7 +10272,7 @@
             <a:r>
               <a:rPr sz="1380" b="0">
                 <a:solidFill>
-                  <a:srgbClr val="55607A"/>
+                  <a:srgbClr val="54607A"/>
                 </a:solidFill>
                 <a:latin typeface="Calibri"/>
               </a:rPr>
@@ -10294,7 +10294,7 @@
             <a:r>
               <a:rPr sz="1380" b="1">
                 <a:solidFill>
-                  <a:srgbClr val="E4A11B"/>
+                  <a:srgbClr val="E6A339"/>
                 </a:solidFill>
                 <a:latin typeface="Calibri"/>
               </a:rPr>
@@ -10303,7 +10303,7 @@
             <a:r>
               <a:rPr sz="1380" b="1">
                 <a:solidFill>
-                  <a:srgbClr val="1A2033"/>
+                  <a:srgbClr val="18243C"/>
                 </a:solidFill>
                 <a:latin typeface="Calibri"/>
               </a:rPr>
@@ -10312,7 +10312,7 @@
             <a:r>
               <a:rPr sz="1380" b="0">
                 <a:solidFill>
-                  <a:srgbClr val="55607A"/>
+                  <a:srgbClr val="54607A"/>
                 </a:solidFill>
                 <a:latin typeface="Calibri"/>
               </a:rPr>
@@ -10334,7 +10334,7 @@
             <a:r>
               <a:rPr sz="1380" b="1">
                 <a:solidFill>
-                  <a:srgbClr val="E4A11B"/>
+                  <a:srgbClr val="E6A339"/>
                 </a:solidFill>
                 <a:latin typeface="Calibri"/>
               </a:rPr>
@@ -10343,7 +10343,7 @@
             <a:r>
               <a:rPr sz="1380" b="1">
                 <a:solidFill>
-                  <a:srgbClr val="1A2033"/>
+                  <a:srgbClr val="18243C"/>
                 </a:solidFill>
                 <a:latin typeface="Calibri"/>
               </a:rPr>
@@ -10352,7 +10352,7 @@
             <a:r>
               <a:rPr sz="1380" b="0">
                 <a:solidFill>
-                  <a:srgbClr val="55607A"/>
+                  <a:srgbClr val="54607A"/>
                 </a:solidFill>
                 <a:latin typeface="Calibri"/>
               </a:rPr>
@@ -10374,7 +10374,7 @@
             <a:r>
               <a:rPr sz="1380" b="1">
                 <a:solidFill>
-                  <a:srgbClr val="E4A11B"/>
+                  <a:srgbClr val="E6A339"/>
                 </a:solidFill>
                 <a:latin typeface="Calibri"/>
               </a:rPr>
@@ -10383,7 +10383,7 @@
             <a:r>
               <a:rPr sz="1380" b="1">
                 <a:solidFill>
-                  <a:srgbClr val="1A2033"/>
+                  <a:srgbClr val="18243C"/>
                 </a:solidFill>
                 <a:latin typeface="Calibri"/>
               </a:rPr>
@@ -10392,7 +10392,7 @@
             <a:r>
               <a:rPr sz="1380" b="0">
                 <a:solidFill>
-                  <a:srgbClr val="55607A"/>
+                  <a:srgbClr val="54607A"/>
                 </a:solidFill>
                 <a:latin typeface="Calibri"/>
               </a:rPr>
@@ -10416,7 +10416,7 @@
             <a:avLst/>
           </a:prstGeom>
           <a:solidFill>
-            <a:srgbClr val="EDF1F6"/>
+            <a:srgbClr val="F7F2E8"/>
           </a:solidFill>
           <a:ln>
             <a:noFill/>
@@ -10460,7 +10460,7 @@
             <a:avLst/>
           </a:prstGeom>
           <a:solidFill>
-            <a:srgbClr val="2E6E9E"/>
+            <a:srgbClr val="3D6A8E"/>
           </a:solidFill>
           <a:ln>
             <a:noFill/>
@@ -10525,16 +10525,16 @@
             <a:r>
               <a:rPr sz="1250" b="1" i="0">
                 <a:solidFill>
-                  <a:srgbClr val="2E6E9E"/>
-                </a:solidFill>
-                <a:latin typeface="Calibri"/>
+                  <a:srgbClr val="3D6A8E"/>
+                </a:solidFill>
+                <a:latin typeface="Georgia"/>
               </a:rPr>
               <a:t>Lien littérature — </a:t>
             </a:r>
             <a:r>
               <a:rPr sz="1250" b="0" i="1">
                 <a:solidFill>
-                  <a:srgbClr val="1A2033"/>
+                  <a:srgbClr val="18243C"/>
                 </a:solidFill>
                 <a:latin typeface="Calibri"/>
               </a:rPr>
@@ -10666,7 +10666,7 @@
             <a:avLst/>
           </a:prstGeom>
           <a:solidFill>
-            <a:srgbClr val="FFFFFF"/>
+            <a:srgbClr val="FCFBF8"/>
           </a:solidFill>
           <a:ln>
             <a:noFill/>
@@ -10710,7 +10710,7 @@
             <a:avLst/>
           </a:prstGeom>
           <a:solidFill>
-            <a:srgbClr val="FFFFFF"/>
+            <a:srgbClr val="FCFBF8"/>
           </a:solidFill>
           <a:ln>
             <a:noFill/>
@@ -10754,7 +10754,7 @@
             <a:avLst/>
           </a:prstGeom>
           <a:solidFill>
-            <a:srgbClr val="E4A11B"/>
+            <a:srgbClr val="E6A339"/>
           </a:solidFill>
           <a:ln>
             <a:noFill/>
@@ -10817,9 +10817,9 @@
               </a:spcAft>
             </a:pPr>
             <a:r>
-              <a:rPr sz="1250" b="1" i="0">
-                <a:solidFill>
-                  <a:srgbClr val="2E6E9E"/>
+              <a:rPr sz="1200" b="1" i="0">
+                <a:solidFill>
+                  <a:srgbClr val="3D6A8E"/>
                 </a:solidFill>
                 <a:latin typeface="Calibri"/>
               </a:rPr>
@@ -10864,9 +10864,9 @@
             <a:r>
               <a:rPr sz="2700" b="1" i="0">
                 <a:solidFill>
-                  <a:srgbClr val="0E2A47"/>
-                </a:solidFill>
-                <a:latin typeface="Calibri"/>
+                  <a:srgbClr val="0B2A4A"/>
+                </a:solidFill>
+                <a:latin typeface="Georgia"/>
               </a:rPr>
               <a:t>Cinq résultats non anticipés par le modèle théorique</a:t>
             </a:r>
@@ -10888,7 +10888,7 @@
             <a:avLst/>
           </a:prstGeom>
           <a:solidFill>
-            <a:srgbClr val="E4A11B"/>
+            <a:srgbClr val="E6A339"/>
           </a:solidFill>
           <a:ln>
             <a:noFill/>
@@ -10938,7 +10938,7 @@
           </a:solidFill>
           <a:ln w="12700">
             <a:solidFill>
-              <a:srgbClr val="D7DDE6"/>
+              <a:srgbClr val="E6DFD3"/>
             </a:solidFill>
           </a:ln>
           <a:effectLst/>
@@ -10980,7 +10980,7 @@
             <a:avLst/>
           </a:prstGeom>
           <a:solidFill>
-            <a:srgbClr val="0E2A47"/>
+            <a:srgbClr val="0B2A4A"/>
           </a:solidFill>
           <a:ln>
             <a:noFill/>
@@ -11024,7 +11024,7 @@
             <a:avLst/>
           </a:prstGeom>
           <a:solidFill>
-            <a:srgbClr val="0E2A47"/>
+            <a:srgbClr val="0B2A4A"/>
           </a:solidFill>
           <a:ln>
             <a:noFill/>
@@ -11089,9 +11089,9 @@
             <a:r>
               <a:rPr sz="2200" b="1" i="0">
                 <a:solidFill>
-                  <a:srgbClr val="E4A11B"/>
-                </a:solidFill>
-                <a:latin typeface="Calibri"/>
+                  <a:srgbClr val="E6A339"/>
+                </a:solidFill>
+                <a:latin typeface="Georgia"/>
               </a:rPr>
               <a:t>1</a:t>
             </a:r>
@@ -11134,9 +11134,9 @@
             <a:r>
               <a:rPr sz="1450" b="1" i="0">
                 <a:solidFill>
-                  <a:srgbClr val="0E2A47"/>
-                </a:solidFill>
-                <a:latin typeface="Calibri"/>
+                  <a:srgbClr val="0B2A4A"/>
+                </a:solidFill>
+                <a:latin typeface="Georgia"/>
               </a:rPr>
               <a:t>Vigilance ≠ refus</a:t>
             </a:r>
@@ -11179,7 +11179,7 @@
             <a:r>
               <a:rPr sz="1200" b="0" i="0">
                 <a:solidFill>
-                  <a:srgbClr val="55607A"/>
+                  <a:srgbClr val="54607A"/>
                 </a:solidFill>
                 <a:latin typeface="Calibri"/>
               </a:rPr>
@@ -11209,7 +11209,7 @@
           </a:solidFill>
           <a:ln w="12700">
             <a:solidFill>
-              <a:srgbClr val="D7DDE6"/>
+              <a:srgbClr val="E6DFD3"/>
             </a:solidFill>
           </a:ln>
           <a:effectLst/>
@@ -11251,7 +11251,7 @@
             <a:avLst/>
           </a:prstGeom>
           <a:solidFill>
-            <a:srgbClr val="0E2A47"/>
+            <a:srgbClr val="0B2A4A"/>
           </a:solidFill>
           <a:ln>
             <a:noFill/>
@@ -11295,7 +11295,7 @@
             <a:avLst/>
           </a:prstGeom>
           <a:solidFill>
-            <a:srgbClr val="0E2A47"/>
+            <a:srgbClr val="0B2A4A"/>
           </a:solidFill>
           <a:ln>
             <a:noFill/>
@@ -11360,9 +11360,9 @@
             <a:r>
               <a:rPr sz="2200" b="1" i="0">
                 <a:solidFill>
-                  <a:srgbClr val="E4A11B"/>
-                </a:solidFill>
-                <a:latin typeface="Calibri"/>
+                  <a:srgbClr val="E6A339"/>
+                </a:solidFill>
+                <a:latin typeface="Georgia"/>
               </a:rPr>
               <a:t>2</a:t>
             </a:r>
@@ -11405,9 +11405,9 @@
             <a:r>
               <a:rPr sz="1450" b="1" i="0">
                 <a:solidFill>
-                  <a:srgbClr val="0E2A47"/>
-                </a:solidFill>
-                <a:latin typeface="Calibri"/>
+                  <a:srgbClr val="0B2A4A"/>
+                </a:solidFill>
+                <a:latin typeface="Georgia"/>
               </a:rPr>
               <a:t>Un seul dirigeant moteur suffit</a:t>
             </a:r>
@@ -11450,7 +11450,7 @@
             <a:r>
               <a:rPr sz="1200" b="0" i="0">
                 <a:solidFill>
-                  <a:srgbClr val="55607A"/>
+                  <a:srgbClr val="54607A"/>
                 </a:solidFill>
                 <a:latin typeface="Calibri"/>
               </a:rPr>
@@ -11480,7 +11480,7 @@
           </a:solidFill>
           <a:ln w="12700">
             <a:solidFill>
-              <a:srgbClr val="D7DDE6"/>
+              <a:srgbClr val="E6DFD3"/>
             </a:solidFill>
           </a:ln>
           <a:effectLst/>
@@ -11522,7 +11522,7 @@
             <a:avLst/>
           </a:prstGeom>
           <a:solidFill>
-            <a:srgbClr val="0E2A47"/>
+            <a:srgbClr val="0B2A4A"/>
           </a:solidFill>
           <a:ln>
             <a:noFill/>
@@ -11566,7 +11566,7 @@
             <a:avLst/>
           </a:prstGeom>
           <a:solidFill>
-            <a:srgbClr val="0E2A47"/>
+            <a:srgbClr val="0B2A4A"/>
           </a:solidFill>
           <a:ln>
             <a:noFill/>
@@ -11631,9 +11631,9 @@
             <a:r>
               <a:rPr sz="2200" b="1" i="0">
                 <a:solidFill>
-                  <a:srgbClr val="E4A11B"/>
-                </a:solidFill>
-                <a:latin typeface="Calibri"/>
+                  <a:srgbClr val="E6A339"/>
+                </a:solidFill>
+                <a:latin typeface="Georgia"/>
               </a:rPr>
               <a:t>3</a:t>
             </a:r>
@@ -11676,9 +11676,9 @@
             <a:r>
               <a:rPr sz="1450" b="1" i="0">
                 <a:solidFill>
-                  <a:srgbClr val="0E2A47"/>
-                </a:solidFill>
-                <a:latin typeface="Calibri"/>
+                  <a:srgbClr val="0B2A4A"/>
+                </a:solidFill>
+                <a:latin typeface="Georgia"/>
               </a:rPr>
               <a:t>Le risque de perte de compétences</a:t>
             </a:r>
@@ -11721,7 +11721,7 @@
             <a:r>
               <a:rPr sz="1200" b="0" i="0">
                 <a:solidFill>
-                  <a:srgbClr val="55607A"/>
+                  <a:srgbClr val="54607A"/>
                 </a:solidFill>
                 <a:latin typeface="Calibri"/>
               </a:rPr>
@@ -11751,7 +11751,7 @@
           </a:solidFill>
           <a:ln w="12700">
             <a:solidFill>
-              <a:srgbClr val="D7DDE6"/>
+              <a:srgbClr val="E6DFD3"/>
             </a:solidFill>
           </a:ln>
           <a:effectLst/>
@@ -11793,7 +11793,7 @@
             <a:avLst/>
           </a:prstGeom>
           <a:solidFill>
-            <a:srgbClr val="0E2A47"/>
+            <a:srgbClr val="0B2A4A"/>
           </a:solidFill>
           <a:ln>
             <a:noFill/>
@@ -11837,7 +11837,7 @@
             <a:avLst/>
           </a:prstGeom>
           <a:solidFill>
-            <a:srgbClr val="0E2A47"/>
+            <a:srgbClr val="0B2A4A"/>
           </a:solidFill>
           <a:ln>
             <a:noFill/>
@@ -11902,9 +11902,9 @@
             <a:r>
               <a:rPr sz="2200" b="1" i="0">
                 <a:solidFill>
-                  <a:srgbClr val="E4A11B"/>
-                </a:solidFill>
-                <a:latin typeface="Calibri"/>
+                  <a:srgbClr val="E6A339"/>
+                </a:solidFill>
+                <a:latin typeface="Georgia"/>
               </a:rPr>
               <a:t>4</a:t>
             </a:r>
@@ -11947,9 +11947,9 @@
             <a:r>
               <a:rPr sz="1450" b="1" i="0">
                 <a:solidFill>
-                  <a:srgbClr val="0E2A47"/>
-                </a:solidFill>
-                <a:latin typeface="Calibri"/>
+                  <a:srgbClr val="0B2A4A"/>
+                </a:solidFill>
+                <a:latin typeface="Georgia"/>
               </a:rPr>
               <a:t>La dimension concurrentielle</a:t>
             </a:r>
@@ -11992,7 +11992,7 @@
             <a:r>
               <a:rPr sz="1200" b="0" i="0">
                 <a:solidFill>
-                  <a:srgbClr val="55607A"/>
+                  <a:srgbClr val="54607A"/>
                 </a:solidFill>
                 <a:latin typeface="Calibri"/>
               </a:rPr>
@@ -12022,7 +12022,7 @@
           </a:solidFill>
           <a:ln w="12700">
             <a:solidFill>
-              <a:srgbClr val="D7DDE6"/>
+              <a:srgbClr val="E6DFD3"/>
             </a:solidFill>
           </a:ln>
           <a:effectLst/>
@@ -12064,7 +12064,7 @@
             <a:avLst/>
           </a:prstGeom>
           <a:solidFill>
-            <a:srgbClr val="0E2A47"/>
+            <a:srgbClr val="0B2A4A"/>
           </a:solidFill>
           <a:ln>
             <a:noFill/>
@@ -12108,7 +12108,7 @@
             <a:avLst/>
           </a:prstGeom>
           <a:solidFill>
-            <a:srgbClr val="0E2A47"/>
+            <a:srgbClr val="0B2A4A"/>
           </a:solidFill>
           <a:ln>
             <a:noFill/>
@@ -12173,9 +12173,9 @@
             <a:r>
               <a:rPr sz="2200" b="1" i="0">
                 <a:solidFill>
-                  <a:srgbClr val="E4A11B"/>
-                </a:solidFill>
-                <a:latin typeface="Calibri"/>
+                  <a:srgbClr val="E6A339"/>
+                </a:solidFill>
+                <a:latin typeface="Georgia"/>
               </a:rPr>
               <a:t>5</a:t>
             </a:r>
@@ -12218,9 +12218,9 @@
             <a:r>
               <a:rPr sz="1450" b="1" i="0">
                 <a:solidFill>
-                  <a:srgbClr val="0E2A47"/>
-                </a:solidFill>
-                <a:latin typeface="Calibri"/>
+                  <a:srgbClr val="0B2A4A"/>
+                </a:solidFill>
+                <a:latin typeface="Georgia"/>
               </a:rPr>
               <a:t>L'« adoption sélective »</a:t>
             </a:r>
@@ -12263,7 +12263,7 @@
             <a:r>
               <a:rPr sz="1200" b="0" i="0">
                 <a:solidFill>
-                  <a:srgbClr val="55607A"/>
+                  <a:srgbClr val="54607A"/>
                 </a:solidFill>
                 <a:latin typeface="Calibri"/>
               </a:rPr>
@@ -12395,7 +12395,7 @@
             <a:avLst/>
           </a:prstGeom>
           <a:solidFill>
-            <a:srgbClr val="0E2A47"/>
+            <a:srgbClr val="0B2A4A"/>
           </a:solidFill>
           <a:ln>
             <a:noFill/>
@@ -12439,7 +12439,7 @@
             <a:avLst/>
           </a:prstGeom>
           <a:solidFill>
-            <a:srgbClr val="E4A11B"/>
+            <a:srgbClr val="E6A339"/>
           </a:solidFill>
           <a:ln>
             <a:noFill/>
@@ -12483,7 +12483,7 @@
             <a:avLst/>
           </a:prstGeom>
           <a:solidFill>
-            <a:srgbClr val="E4A11B"/>
+            <a:srgbClr val="E6A339"/>
           </a:solidFill>
           <a:ln>
             <a:noFill/>
@@ -12550,7 +12550,7 @@
                 <a:solidFill>
                   <a:srgbClr val="24466B"/>
                 </a:solidFill>
-                <a:latin typeface="Calibri"/>
+                <a:latin typeface="Georgia"/>
               </a:rPr>
               <a:t>05</a:t>
             </a:r>
@@ -12595,7 +12595,7 @@
                 <a:solidFill>
                   <a:srgbClr val="FFFFFF"/>
                 </a:solidFill>
-                <a:latin typeface="Calibri"/>
+                <a:latin typeface="Georgia"/>
               </a:rPr>
               <a:t>Apports &amp; préconisations</a:t>
             </a:r>
@@ -12770,7 +12770,7 @@
             <a:avLst/>
           </a:prstGeom>
           <a:solidFill>
-            <a:srgbClr val="FFFFFF"/>
+            <a:srgbClr val="FCFBF8"/>
           </a:solidFill>
           <a:ln>
             <a:noFill/>
@@ -12814,7 +12814,7 @@
             <a:avLst/>
           </a:prstGeom>
           <a:solidFill>
-            <a:srgbClr val="FFFFFF"/>
+            <a:srgbClr val="FCFBF8"/>
           </a:solidFill>
           <a:ln>
             <a:noFill/>
@@ -12858,7 +12858,7 @@
             <a:avLst/>
           </a:prstGeom>
           <a:solidFill>
-            <a:srgbClr val="E4A11B"/>
+            <a:srgbClr val="E6A339"/>
           </a:solidFill>
           <a:ln>
             <a:noFill/>
@@ -12921,9 +12921,9 @@
               </a:spcAft>
             </a:pPr>
             <a:r>
-              <a:rPr sz="1250" b="1" i="0">
-                <a:solidFill>
-                  <a:srgbClr val="2E6E9E"/>
+              <a:rPr sz="1200" b="1" i="0">
+                <a:solidFill>
+                  <a:srgbClr val="3D6A8E"/>
                 </a:solidFill>
                 <a:latin typeface="Calibri"/>
               </a:rPr>
@@ -12968,9 +12968,9 @@
             <a:r>
               <a:rPr sz="2700" b="1" i="0">
                 <a:solidFill>
-                  <a:srgbClr val="0E2A47"/>
-                </a:solidFill>
-                <a:latin typeface="Calibri"/>
+                  <a:srgbClr val="0B2A4A"/>
+                </a:solidFill>
+                <a:latin typeface="Georgia"/>
               </a:rPr>
               <a:t>Trois leviers pour une intégration durable de l'IA</a:t>
             </a:r>
@@ -12992,7 +12992,7 @@
             <a:avLst/>
           </a:prstGeom>
           <a:solidFill>
-            <a:srgbClr val="E4A11B"/>
+            <a:srgbClr val="E6A339"/>
           </a:solidFill>
           <a:ln>
             <a:noFill/>
@@ -13042,7 +13042,7 @@
           </a:solidFill>
           <a:ln w="12700">
             <a:solidFill>
-              <a:srgbClr val="D7DDE6"/>
+              <a:srgbClr val="E6DFD3"/>
             </a:solidFill>
           </a:ln>
           <a:effectLst/>
@@ -13084,7 +13084,7 @@
             <a:avLst/>
           </a:prstGeom>
           <a:solidFill>
-            <a:srgbClr val="0E2A47"/>
+            <a:srgbClr val="0B2A4A"/>
           </a:solidFill>
           <a:ln>
             <a:noFill/>
@@ -13128,7 +13128,7 @@
             <a:avLst/>
           </a:prstGeom>
           <a:solidFill>
-            <a:srgbClr val="0E2A47"/>
+            <a:srgbClr val="0B2A4A"/>
           </a:solidFill>
           <a:ln>
             <a:noFill/>
@@ -13193,9 +13193,9 @@
             <a:r>
               <a:rPr sz="3000" b="1" i="0">
                 <a:solidFill>
-                  <a:srgbClr val="E4A11B"/>
-                </a:solidFill>
-                <a:latin typeface="Calibri"/>
+                  <a:srgbClr val="E6A339"/>
+                </a:solidFill>
+                <a:latin typeface="Georgia"/>
               </a:rPr>
               <a:t>01</a:t>
             </a:r>
@@ -13240,7 +13240,7 @@
                 <a:solidFill>
                   <a:srgbClr val="FFFFFF"/>
                 </a:solidFill>
-                <a:latin typeface="Calibri"/>
+                <a:latin typeface="Georgia"/>
               </a:rPr>
               <a:t>Structurer une politique commune</a:t>
             </a:r>
@@ -13283,7 +13283,7 @@
             <a:r>
               <a:rPr sz="1150" b="0" i="1">
                 <a:solidFill>
-                  <a:srgbClr val="2E6E9E"/>
+                  <a:srgbClr val="3D6A8E"/>
                 </a:solidFill>
                 <a:latin typeface="Calibri"/>
               </a:rPr>
@@ -13328,7 +13328,7 @@
             <a:r>
               <a:rPr sz="1200" b="1">
                 <a:solidFill>
-                  <a:srgbClr val="E4A11B"/>
+                  <a:srgbClr val="E6A339"/>
                 </a:solidFill>
                 <a:latin typeface="Calibri"/>
               </a:rPr>
@@ -13337,7 +13337,7 @@
             <a:r>
               <a:rPr sz="1200">
                 <a:solidFill>
-                  <a:srgbClr val="1A2033"/>
+                  <a:srgbClr val="18243C"/>
                 </a:solidFill>
                 <a:latin typeface="Calibri"/>
               </a:rPr>
@@ -13359,7 +13359,7 @@
             <a:r>
               <a:rPr sz="1200" b="1">
                 <a:solidFill>
-                  <a:srgbClr val="E4A11B"/>
+                  <a:srgbClr val="E6A339"/>
                 </a:solidFill>
                 <a:latin typeface="Calibri"/>
               </a:rPr>
@@ -13368,7 +13368,7 @@
             <a:r>
               <a:rPr sz="1200">
                 <a:solidFill>
-                  <a:srgbClr val="1A2033"/>
+                  <a:srgbClr val="18243C"/>
                 </a:solidFill>
                 <a:latin typeface="Calibri"/>
               </a:rPr>
@@ -13390,7 +13390,7 @@
             <a:r>
               <a:rPr sz="1200" b="1">
                 <a:solidFill>
-                  <a:srgbClr val="E4A11B"/>
+                  <a:srgbClr val="E6A339"/>
                 </a:solidFill>
                 <a:latin typeface="Calibri"/>
               </a:rPr>
@@ -13399,7 +13399,7 @@
             <a:r>
               <a:rPr sz="1200">
                 <a:solidFill>
-                  <a:srgbClr val="1A2033"/>
+                  <a:srgbClr val="18243C"/>
                 </a:solidFill>
                 <a:latin typeface="Calibri"/>
               </a:rPr>
@@ -13423,7 +13423,7 @@
             <a:avLst/>
           </a:prstGeom>
           <a:solidFill>
-            <a:srgbClr val="EDF1F6"/>
+            <a:srgbClr val="F7F2E8"/>
           </a:solidFill>
           <a:ln>
             <a:noFill/>
@@ -13488,7 +13488,7 @@
             <a:r>
               <a:rPr sz="1050" b="1" i="1">
                 <a:solidFill>
-                  <a:srgbClr val="C6860E"/>
+                  <a:srgbClr val="AF7112"/>
                 </a:solidFill>
                 <a:latin typeface="Calibri"/>
               </a:rPr>
@@ -13518,7 +13518,7 @@
           </a:solidFill>
           <a:ln w="12700">
             <a:solidFill>
-              <a:srgbClr val="D7DDE6"/>
+              <a:srgbClr val="E6DFD3"/>
             </a:solidFill>
           </a:ln>
           <a:effectLst/>
@@ -13560,7 +13560,7 @@
             <a:avLst/>
           </a:prstGeom>
           <a:solidFill>
-            <a:srgbClr val="0E2A47"/>
+            <a:srgbClr val="0B2A4A"/>
           </a:solidFill>
           <a:ln>
             <a:noFill/>
@@ -13604,7 +13604,7 @@
             <a:avLst/>
           </a:prstGeom>
           <a:solidFill>
-            <a:srgbClr val="0E2A47"/>
+            <a:srgbClr val="0B2A4A"/>
           </a:solidFill>
           <a:ln>
             <a:noFill/>
@@ -13669,9 +13669,9 @@
             <a:r>
               <a:rPr sz="3000" b="1" i="0">
                 <a:solidFill>
-                  <a:srgbClr val="E4A11B"/>
-                </a:solidFill>
-                <a:latin typeface="Calibri"/>
+                  <a:srgbClr val="E6A339"/>
+                </a:solidFill>
+                <a:latin typeface="Georgia"/>
               </a:rPr>
               <a:t>02</a:t>
             </a:r>
@@ -13716,7 +13716,7 @@
                 <a:solidFill>
                   <a:srgbClr val="FFFFFF"/>
                 </a:solidFill>
-                <a:latin typeface="Calibri"/>
+                <a:latin typeface="Georgia"/>
               </a:rPr>
               <a:t>Déployer une formation différenciée</a:t>
             </a:r>
@@ -13759,7 +13759,7 @@
             <a:r>
               <a:rPr sz="1150" b="0" i="1">
                 <a:solidFill>
-                  <a:srgbClr val="2E6E9E"/>
+                  <a:srgbClr val="3D6A8E"/>
                 </a:solidFill>
                 <a:latin typeface="Calibri"/>
               </a:rPr>
@@ -13804,7 +13804,7 @@
             <a:r>
               <a:rPr sz="1200" b="1">
                 <a:solidFill>
-                  <a:srgbClr val="E4A11B"/>
+                  <a:srgbClr val="E6A339"/>
                 </a:solidFill>
                 <a:latin typeface="Calibri"/>
               </a:rPr>
@@ -13813,7 +13813,7 @@
             <a:r>
               <a:rPr sz="1200">
                 <a:solidFill>
-                  <a:srgbClr val="1A2033"/>
+                  <a:srgbClr val="18243C"/>
                 </a:solidFill>
                 <a:latin typeface="Calibri"/>
               </a:rPr>
@@ -13835,7 +13835,7 @@
             <a:r>
               <a:rPr sz="1200" b="1">
                 <a:solidFill>
-                  <a:srgbClr val="E4A11B"/>
+                  <a:srgbClr val="E6A339"/>
                 </a:solidFill>
                 <a:latin typeface="Calibri"/>
               </a:rPr>
@@ -13844,7 +13844,7 @@
             <a:r>
               <a:rPr sz="1200">
                 <a:solidFill>
-                  <a:srgbClr val="1A2033"/>
+                  <a:srgbClr val="18243C"/>
                 </a:solidFill>
                 <a:latin typeface="Calibri"/>
               </a:rPr>
@@ -13866,7 +13866,7 @@
             <a:r>
               <a:rPr sz="1200" b="1">
                 <a:solidFill>
-                  <a:srgbClr val="E4A11B"/>
+                  <a:srgbClr val="E6A339"/>
                 </a:solidFill>
                 <a:latin typeface="Calibri"/>
               </a:rPr>
@@ -13875,7 +13875,7 @@
             <a:r>
               <a:rPr sz="1200">
                 <a:solidFill>
-                  <a:srgbClr val="1A2033"/>
+                  <a:srgbClr val="18243C"/>
                 </a:solidFill>
                 <a:latin typeface="Calibri"/>
               </a:rPr>
@@ -13899,7 +13899,7 @@
             <a:avLst/>
           </a:prstGeom>
           <a:solidFill>
-            <a:srgbClr val="EDF1F6"/>
+            <a:srgbClr val="F7F2E8"/>
           </a:solidFill>
           <a:ln>
             <a:noFill/>
@@ -13964,7 +13964,7 @@
             <a:r>
               <a:rPr sz="1050" b="1" i="1">
                 <a:solidFill>
-                  <a:srgbClr val="C6860E"/>
+                  <a:srgbClr val="AF7112"/>
                 </a:solidFill>
                 <a:latin typeface="Calibri"/>
               </a:rPr>
@@ -13994,7 +13994,7 @@
           </a:solidFill>
           <a:ln w="12700">
             <a:solidFill>
-              <a:srgbClr val="D7DDE6"/>
+              <a:srgbClr val="E6DFD3"/>
             </a:solidFill>
           </a:ln>
           <a:effectLst/>
@@ -14036,7 +14036,7 @@
             <a:avLst/>
           </a:prstGeom>
           <a:solidFill>
-            <a:srgbClr val="0E2A47"/>
+            <a:srgbClr val="0B2A4A"/>
           </a:solidFill>
           <a:ln>
             <a:noFill/>
@@ -14080,7 +14080,7 @@
             <a:avLst/>
           </a:prstGeom>
           <a:solidFill>
-            <a:srgbClr val="0E2A47"/>
+            <a:srgbClr val="0B2A4A"/>
           </a:solidFill>
           <a:ln>
             <a:noFill/>
@@ -14145,9 +14145,9 @@
             <a:r>
               <a:rPr sz="3000" b="1" i="0">
                 <a:solidFill>
-                  <a:srgbClr val="E4A11B"/>
-                </a:solidFill>
-                <a:latin typeface="Calibri"/>
+                  <a:srgbClr val="E6A339"/>
+                </a:solidFill>
+                <a:latin typeface="Georgia"/>
               </a:rPr>
               <a:t>03</a:t>
             </a:r>
@@ -14192,7 +14192,7 @@
                 <a:solidFill>
                   <a:srgbClr val="FFFFFF"/>
                 </a:solidFill>
-                <a:latin typeface="Calibri"/>
+                <a:latin typeface="Georgia"/>
               </a:rPr>
               <a:t>Adopter une démarche participative</a:t>
             </a:r>
@@ -14235,7 +14235,7 @@
             <a:r>
               <a:rPr sz="1150" b="0" i="1">
                 <a:solidFill>
-                  <a:srgbClr val="2E6E9E"/>
+                  <a:srgbClr val="3D6A8E"/>
                 </a:solidFill>
                 <a:latin typeface="Calibri"/>
               </a:rPr>
@@ -14280,7 +14280,7 @@
             <a:r>
               <a:rPr sz="1200" b="1">
                 <a:solidFill>
-                  <a:srgbClr val="E4A11B"/>
+                  <a:srgbClr val="E6A339"/>
                 </a:solidFill>
                 <a:latin typeface="Calibri"/>
               </a:rPr>
@@ -14289,7 +14289,7 @@
             <a:r>
               <a:rPr sz="1200">
                 <a:solidFill>
-                  <a:srgbClr val="1A2033"/>
+                  <a:srgbClr val="18243C"/>
                 </a:solidFill>
                 <a:latin typeface="Calibri"/>
               </a:rPr>
@@ -14311,7 +14311,7 @@
             <a:r>
               <a:rPr sz="1200" b="1">
                 <a:solidFill>
-                  <a:srgbClr val="E4A11B"/>
+                  <a:srgbClr val="E6A339"/>
                 </a:solidFill>
                 <a:latin typeface="Calibri"/>
               </a:rPr>
@@ -14320,7 +14320,7 @@
             <a:r>
               <a:rPr sz="1200">
                 <a:solidFill>
-                  <a:srgbClr val="1A2033"/>
+                  <a:srgbClr val="18243C"/>
                 </a:solidFill>
                 <a:latin typeface="Calibri"/>
               </a:rPr>
@@ -14342,7 +14342,7 @@
             <a:r>
               <a:rPr sz="1200" b="1">
                 <a:solidFill>
-                  <a:srgbClr val="E4A11B"/>
+                  <a:srgbClr val="E6A339"/>
                 </a:solidFill>
                 <a:latin typeface="Calibri"/>
               </a:rPr>
@@ -14351,7 +14351,7 @@
             <a:r>
               <a:rPr sz="1200">
                 <a:solidFill>
-                  <a:srgbClr val="1A2033"/>
+                  <a:srgbClr val="18243C"/>
                 </a:solidFill>
                 <a:latin typeface="Calibri"/>
               </a:rPr>
@@ -14375,7 +14375,7 @@
             <a:avLst/>
           </a:prstGeom>
           <a:solidFill>
-            <a:srgbClr val="EDF1F6"/>
+            <a:srgbClr val="F7F2E8"/>
           </a:solidFill>
           <a:ln>
             <a:noFill/>
@@ -14440,7 +14440,7 @@
             <a:r>
               <a:rPr sz="1050" b="1" i="1">
                 <a:solidFill>
-                  <a:srgbClr val="C6860E"/>
+                  <a:srgbClr val="AF7112"/>
                 </a:solidFill>
                 <a:latin typeface="Calibri"/>
               </a:rPr>
@@ -14572,7 +14572,7 @@
             <a:avLst/>
           </a:prstGeom>
           <a:solidFill>
-            <a:srgbClr val="FFFFFF"/>
+            <a:srgbClr val="FCFBF8"/>
           </a:solidFill>
           <a:ln>
             <a:noFill/>
@@ -14616,7 +14616,7 @@
             <a:avLst/>
           </a:prstGeom>
           <a:solidFill>
-            <a:srgbClr val="FFFFFF"/>
+            <a:srgbClr val="FCFBF8"/>
           </a:solidFill>
           <a:ln>
             <a:noFill/>
@@ -14660,7 +14660,7 @@
             <a:avLst/>
           </a:prstGeom>
           <a:solidFill>
-            <a:srgbClr val="E4A11B"/>
+            <a:srgbClr val="E6A339"/>
           </a:solidFill>
           <a:ln>
             <a:noFill/>
@@ -14723,9 +14723,9 @@
               </a:spcAft>
             </a:pPr>
             <a:r>
-              <a:rPr sz="1250" b="1" i="0">
-                <a:solidFill>
-                  <a:srgbClr val="2E6E9E"/>
+              <a:rPr sz="1200" b="1" i="0">
+                <a:solidFill>
+                  <a:srgbClr val="3D6A8E"/>
                 </a:solidFill>
                 <a:latin typeface="Calibri"/>
               </a:rPr>
@@ -14770,9 +14770,9 @@
             <a:r>
               <a:rPr sz="2700" b="1" i="0">
                 <a:solidFill>
-                  <a:srgbClr val="0E2A47"/>
-                </a:solidFill>
-                <a:latin typeface="Calibri"/>
+                  <a:srgbClr val="0B2A4A"/>
+                </a:solidFill>
+                <a:latin typeface="Georgia"/>
               </a:rPr>
               <a:t>Ce que ce mémoire m'apporte, et apporte à l'entreprise</a:t>
             </a:r>
@@ -14794,7 +14794,7 @@
             <a:avLst/>
           </a:prstGeom>
           <a:solidFill>
-            <a:srgbClr val="E4A11B"/>
+            <a:srgbClr val="E6A339"/>
           </a:solidFill>
           <a:ln>
             <a:noFill/>
@@ -14844,7 +14844,7 @@
           </a:solidFill>
           <a:ln w="12700">
             <a:solidFill>
-              <a:srgbClr val="D7DDE6"/>
+              <a:srgbClr val="E6DFD3"/>
             </a:solidFill>
           </a:ln>
           <a:effectLst/>
@@ -14886,7 +14886,7 @@
             <a:avLst/>
           </a:prstGeom>
           <a:solidFill>
-            <a:srgbClr val="E4A11B"/>
+            <a:srgbClr val="E6A339"/>
           </a:solidFill>
           <a:ln>
             <a:noFill/>
@@ -14951,9 +14951,9 @@
             <a:r>
               <a:rPr sz="1500" b="1" i="0">
                 <a:solidFill>
-                  <a:srgbClr val="0E2A47"/>
-                </a:solidFill>
-                <a:latin typeface="Calibri"/>
+                  <a:srgbClr val="0B2A4A"/>
+                </a:solidFill>
+                <a:latin typeface="Georgia"/>
               </a:rPr>
               <a:t>Une posture de conduite du changement</a:t>
             </a:r>
@@ -14996,7 +14996,7 @@
             <a:r>
               <a:rPr sz="1250" b="0" i="0">
                 <a:solidFill>
-                  <a:srgbClr val="55607A"/>
+                  <a:srgbClr val="54607A"/>
                 </a:solidFill>
                 <a:latin typeface="Calibri"/>
               </a:rPr>
@@ -15026,7 +15026,7 @@
           </a:solidFill>
           <a:ln w="12700">
             <a:solidFill>
-              <a:srgbClr val="D7DDE6"/>
+              <a:srgbClr val="E6DFD3"/>
             </a:solidFill>
           </a:ln>
           <a:effectLst/>
@@ -15068,7 +15068,7 @@
             <a:avLst/>
           </a:prstGeom>
           <a:solidFill>
-            <a:srgbClr val="E4A11B"/>
+            <a:srgbClr val="E6A339"/>
           </a:solidFill>
           <a:ln>
             <a:noFill/>
@@ -15133,9 +15133,9 @@
             <a:r>
               <a:rPr sz="1500" b="1" i="0">
                 <a:solidFill>
-                  <a:srgbClr val="0E2A47"/>
-                </a:solidFill>
-                <a:latin typeface="Calibri"/>
+                  <a:srgbClr val="0B2A4A"/>
+                </a:solidFill>
+                <a:latin typeface="Georgia"/>
               </a:rPr>
               <a:t>Des compétences d'analyse</a:t>
             </a:r>
@@ -15178,7 +15178,7 @@
             <a:r>
               <a:rPr sz="1250" b="0" i="0">
                 <a:solidFill>
-                  <a:srgbClr val="55607A"/>
+                  <a:srgbClr val="54607A"/>
                 </a:solidFill>
                 <a:latin typeface="Calibri"/>
               </a:rPr>
@@ -15208,7 +15208,7 @@
           </a:solidFill>
           <a:ln w="12700">
             <a:solidFill>
-              <a:srgbClr val="D7DDE6"/>
+              <a:srgbClr val="E6DFD3"/>
             </a:solidFill>
           </a:ln>
           <a:effectLst/>
@@ -15250,7 +15250,7 @@
             <a:avLst/>
           </a:prstGeom>
           <a:solidFill>
-            <a:srgbClr val="2E6E9E"/>
+            <a:srgbClr val="3D6A8E"/>
           </a:solidFill>
           <a:ln>
             <a:noFill/>
@@ -15315,9 +15315,9 @@
             <a:r>
               <a:rPr sz="1500" b="1" i="0">
                 <a:solidFill>
-                  <a:srgbClr val="0E2A47"/>
-                </a:solidFill>
-                <a:latin typeface="Calibri"/>
+                  <a:srgbClr val="0B2A4A"/>
+                </a:solidFill>
+                <a:latin typeface="Georgia"/>
               </a:rPr>
               <a:t>Un livrable directement actionnable</a:t>
             </a:r>
@@ -15360,7 +15360,7 @@
             <a:r>
               <a:rPr sz="1250" b="0" i="0">
                 <a:solidFill>
-                  <a:srgbClr val="55607A"/>
+                  <a:srgbClr val="54607A"/>
                 </a:solidFill>
                 <a:latin typeface="Calibri"/>
               </a:rPr>
@@ -15390,7 +15390,7 @@
           </a:solidFill>
           <a:ln w="12700">
             <a:solidFill>
-              <a:srgbClr val="D7DDE6"/>
+              <a:srgbClr val="E6DFD3"/>
             </a:solidFill>
           </a:ln>
           <a:effectLst/>
@@ -15432,7 +15432,7 @@
             <a:avLst/>
           </a:prstGeom>
           <a:solidFill>
-            <a:srgbClr val="2E6E9E"/>
+            <a:srgbClr val="3D6A8E"/>
           </a:solidFill>
           <a:ln>
             <a:noFill/>
@@ -15497,9 +15497,9 @@
             <a:r>
               <a:rPr sz="1500" b="1" i="0">
                 <a:solidFill>
-                  <a:srgbClr val="0E2A47"/>
-                </a:solidFill>
-                <a:latin typeface="Calibri"/>
+                  <a:srgbClr val="0B2A4A"/>
+                </a:solidFill>
+                <a:latin typeface="Georgia"/>
               </a:rPr>
               <a:t>Une vision stratégique du numérique</a:t>
             </a:r>
@@ -15542,7 +15542,7 @@
             <a:r>
               <a:rPr sz="1250" b="0" i="0">
                 <a:solidFill>
-                  <a:srgbClr val="55607A"/>
+                  <a:srgbClr val="54607A"/>
                 </a:solidFill>
                 <a:latin typeface="Calibri"/>
               </a:rPr>
@@ -15674,7 +15674,7 @@
             <a:avLst/>
           </a:prstGeom>
           <a:solidFill>
-            <a:srgbClr val="FFFFFF"/>
+            <a:srgbClr val="FCFBF8"/>
           </a:solidFill>
           <a:ln>
             <a:noFill/>
@@ -15718,7 +15718,7 @@
             <a:avLst/>
           </a:prstGeom>
           <a:solidFill>
-            <a:srgbClr val="FFFFFF"/>
+            <a:srgbClr val="FCFBF8"/>
           </a:solidFill>
           <a:ln>
             <a:noFill/>
@@ -15762,7 +15762,7 @@
             <a:avLst/>
           </a:prstGeom>
           <a:solidFill>
-            <a:srgbClr val="E4A11B"/>
+            <a:srgbClr val="E6A339"/>
           </a:solidFill>
           <a:ln>
             <a:noFill/>
@@ -15825,9 +15825,9 @@
               </a:spcAft>
             </a:pPr>
             <a:r>
-              <a:rPr sz="1250" b="1" i="0">
-                <a:solidFill>
-                  <a:srgbClr val="2E6E9E"/>
+              <a:rPr sz="1200" b="1" i="0">
+                <a:solidFill>
+                  <a:srgbClr val="3D6A8E"/>
                 </a:solidFill>
                 <a:latin typeface="Calibri"/>
               </a:rPr>
@@ -15872,9 +15872,9 @@
             <a:r>
               <a:rPr sz="2700" b="1" i="0">
                 <a:solidFill>
-                  <a:srgbClr val="0E2A47"/>
-                </a:solidFill>
-                <a:latin typeface="Calibri"/>
+                  <a:srgbClr val="0B2A4A"/>
+                </a:solidFill>
+                <a:latin typeface="Georgia"/>
               </a:rPr>
               <a:t>Plan de la soutenance</a:t>
             </a:r>
@@ -15896,7 +15896,7 @@
             <a:avLst/>
           </a:prstGeom>
           <a:solidFill>
-            <a:srgbClr val="E4A11B"/>
+            <a:srgbClr val="E6A339"/>
           </a:solidFill>
           <a:ln>
             <a:noFill/>
@@ -15946,7 +15946,7 @@
           </a:solidFill>
           <a:ln w="12700">
             <a:solidFill>
-              <a:srgbClr val="D7DDE6"/>
+              <a:srgbClr val="E6DFD3"/>
             </a:solidFill>
           </a:ln>
           <a:effectLst/>
@@ -15988,7 +15988,7 @@
             <a:avLst/>
           </a:prstGeom>
           <a:solidFill>
-            <a:srgbClr val="E4A11B"/>
+            <a:srgbClr val="E6A339"/>
           </a:solidFill>
           <a:ln>
             <a:noFill/>
@@ -16055,7 +16055,7 @@
                 <a:solidFill>
                   <a:srgbClr val="E1E7EF"/>
                 </a:solidFill>
-                <a:latin typeface="Calibri"/>
+                <a:latin typeface="Georgia"/>
               </a:rPr>
               <a:t>01</a:t>
             </a:r>
@@ -16098,9 +16098,9 @@
             <a:r>
               <a:rPr sz="1650" b="1" i="0">
                 <a:solidFill>
-                  <a:srgbClr val="0E2A47"/>
-                </a:solidFill>
-                <a:latin typeface="Calibri"/>
+                  <a:srgbClr val="0B2A4A"/>
+                </a:solidFill>
+                <a:latin typeface="Georgia"/>
               </a:rPr>
               <a:t>Contexte &amp; problématique</a:t>
             </a:r>
@@ -16143,7 +16143,7 @@
             <a:r>
               <a:rPr sz="1150" b="0" i="0">
                 <a:solidFill>
-                  <a:srgbClr val="55607A"/>
+                  <a:srgbClr val="54607A"/>
                 </a:solidFill>
                 <a:latin typeface="Calibri"/>
               </a:rPr>
@@ -16173,7 +16173,7 @@
           </a:solidFill>
           <a:ln w="12700">
             <a:solidFill>
-              <a:srgbClr val="D7DDE6"/>
+              <a:srgbClr val="E6DFD3"/>
             </a:solidFill>
           </a:ln>
           <a:effectLst/>
@@ -16215,7 +16215,7 @@
             <a:avLst/>
           </a:prstGeom>
           <a:solidFill>
-            <a:srgbClr val="E4A11B"/>
+            <a:srgbClr val="E6A339"/>
           </a:solidFill>
           <a:ln>
             <a:noFill/>
@@ -16282,7 +16282,7 @@
                 <a:solidFill>
                   <a:srgbClr val="E1E7EF"/>
                 </a:solidFill>
-                <a:latin typeface="Calibri"/>
+                <a:latin typeface="Georgia"/>
               </a:rPr>
               <a:t>02</a:t>
             </a:r>
@@ -16325,9 +16325,9 @@
             <a:r>
               <a:rPr sz="1650" b="1" i="0">
                 <a:solidFill>
-                  <a:srgbClr val="0E2A47"/>
-                </a:solidFill>
-                <a:latin typeface="Calibri"/>
+                  <a:srgbClr val="0B2A4A"/>
+                </a:solidFill>
+                <a:latin typeface="Georgia"/>
               </a:rPr>
               <a:t>Cadre théorique &amp; propositions</a:t>
             </a:r>
@@ -16370,7 +16370,7 @@
             <a:r>
               <a:rPr sz="1150" b="0" i="0">
                 <a:solidFill>
-                  <a:srgbClr val="55607A"/>
+                  <a:srgbClr val="54607A"/>
                 </a:solidFill>
                 <a:latin typeface="Calibri"/>
               </a:rPr>
@@ -16400,7 +16400,7 @@
           </a:solidFill>
           <a:ln w="12700">
             <a:solidFill>
-              <a:srgbClr val="D7DDE6"/>
+              <a:srgbClr val="E6DFD3"/>
             </a:solidFill>
           </a:ln>
           <a:effectLst/>
@@ -16442,7 +16442,7 @@
             <a:avLst/>
           </a:prstGeom>
           <a:solidFill>
-            <a:srgbClr val="E4A11B"/>
+            <a:srgbClr val="E6A339"/>
           </a:solidFill>
           <a:ln>
             <a:noFill/>
@@ -16509,7 +16509,7 @@
                 <a:solidFill>
                   <a:srgbClr val="E1E7EF"/>
                 </a:solidFill>
-                <a:latin typeface="Calibri"/>
+                <a:latin typeface="Georgia"/>
               </a:rPr>
               <a:t>03</a:t>
             </a:r>
@@ -16552,9 +16552,9 @@
             <a:r>
               <a:rPr sz="1650" b="1" i="0">
                 <a:solidFill>
-                  <a:srgbClr val="0E2A47"/>
-                </a:solidFill>
-                <a:latin typeface="Calibri"/>
+                  <a:srgbClr val="0B2A4A"/>
+                </a:solidFill>
+                <a:latin typeface="Georgia"/>
               </a:rPr>
               <a:t>Méthodologie empirique</a:t>
             </a:r>
@@ -16597,7 +16597,7 @@
             <a:r>
               <a:rPr sz="1150" b="0" i="0">
                 <a:solidFill>
-                  <a:srgbClr val="55607A"/>
+                  <a:srgbClr val="54607A"/>
                 </a:solidFill>
                 <a:latin typeface="Calibri"/>
               </a:rPr>
@@ -16627,7 +16627,7 @@
           </a:solidFill>
           <a:ln w="12700">
             <a:solidFill>
-              <a:srgbClr val="D7DDE6"/>
+              <a:srgbClr val="E6DFD3"/>
             </a:solidFill>
           </a:ln>
           <a:effectLst/>
@@ -16669,7 +16669,7 @@
             <a:avLst/>
           </a:prstGeom>
           <a:solidFill>
-            <a:srgbClr val="2E6E9E"/>
+            <a:srgbClr val="3D6A8E"/>
           </a:solidFill>
           <a:ln>
             <a:noFill/>
@@ -16736,7 +16736,7 @@
                 <a:solidFill>
                   <a:srgbClr val="E1E7EF"/>
                 </a:solidFill>
-                <a:latin typeface="Calibri"/>
+                <a:latin typeface="Georgia"/>
               </a:rPr>
               <a:t>04</a:t>
             </a:r>
@@ -16779,9 +16779,9 @@
             <a:r>
               <a:rPr sz="1650" b="1" i="0">
                 <a:solidFill>
-                  <a:srgbClr val="0E2A47"/>
-                </a:solidFill>
-                <a:latin typeface="Calibri"/>
+                  <a:srgbClr val="0B2A4A"/>
+                </a:solidFill>
+                <a:latin typeface="Georgia"/>
               </a:rPr>
               <a:t>Résultats &amp; analyse</a:t>
             </a:r>
@@ -16824,7 +16824,7 @@
             <a:r>
               <a:rPr sz="1150" b="0" i="0">
                 <a:solidFill>
-                  <a:srgbClr val="55607A"/>
+                  <a:srgbClr val="54607A"/>
                 </a:solidFill>
                 <a:latin typeface="Calibri"/>
               </a:rPr>
@@ -16854,7 +16854,7 @@
           </a:solidFill>
           <a:ln w="12700">
             <a:solidFill>
-              <a:srgbClr val="D7DDE6"/>
+              <a:srgbClr val="E6DFD3"/>
             </a:solidFill>
           </a:ln>
           <a:effectLst/>
@@ -16896,7 +16896,7 @@
             <a:avLst/>
           </a:prstGeom>
           <a:solidFill>
-            <a:srgbClr val="2E6E9E"/>
+            <a:srgbClr val="3D6A8E"/>
           </a:solidFill>
           <a:ln>
             <a:noFill/>
@@ -16963,7 +16963,7 @@
                 <a:solidFill>
                   <a:srgbClr val="E1E7EF"/>
                 </a:solidFill>
-                <a:latin typeface="Calibri"/>
+                <a:latin typeface="Georgia"/>
               </a:rPr>
               <a:t>05</a:t>
             </a:r>
@@ -17006,9 +17006,9 @@
             <a:r>
               <a:rPr sz="1650" b="1" i="0">
                 <a:solidFill>
-                  <a:srgbClr val="0E2A47"/>
-                </a:solidFill>
-                <a:latin typeface="Calibri"/>
+                  <a:srgbClr val="0B2A4A"/>
+                </a:solidFill>
+                <a:latin typeface="Georgia"/>
               </a:rPr>
               <a:t>Apports &amp; préconisations</a:t>
             </a:r>
@@ -17051,7 +17051,7 @@
             <a:r>
               <a:rPr sz="1150" b="0" i="0">
                 <a:solidFill>
-                  <a:srgbClr val="55607A"/>
+                  <a:srgbClr val="54607A"/>
                 </a:solidFill>
                 <a:latin typeface="Calibri"/>
               </a:rPr>
@@ -17081,7 +17081,7 @@
           </a:solidFill>
           <a:ln w="12700">
             <a:solidFill>
-              <a:srgbClr val="D7DDE6"/>
+              <a:srgbClr val="E6DFD3"/>
             </a:solidFill>
           </a:ln>
           <a:effectLst/>
@@ -17123,7 +17123,7 @@
             <a:avLst/>
           </a:prstGeom>
           <a:solidFill>
-            <a:srgbClr val="2E6E9E"/>
+            <a:srgbClr val="3D6A8E"/>
           </a:solidFill>
           <a:ln>
             <a:noFill/>
@@ -17190,7 +17190,7 @@
                 <a:solidFill>
                   <a:srgbClr val="E1E7EF"/>
                 </a:solidFill>
-                <a:latin typeface="Calibri"/>
+                <a:latin typeface="Georgia"/>
               </a:rPr>
               <a:t>06</a:t>
             </a:r>
@@ -17233,9 +17233,9 @@
             <a:r>
               <a:rPr sz="1650" b="1" i="0">
                 <a:solidFill>
-                  <a:srgbClr val="0E2A47"/>
-                </a:solidFill>
-                <a:latin typeface="Calibri"/>
+                  <a:srgbClr val="0B2A4A"/>
+                </a:solidFill>
+                <a:latin typeface="Georgia"/>
               </a:rPr>
               <a:t>Conclusion &amp; limites</a:t>
             </a:r>
@@ -17278,7 +17278,7 @@
             <a:r>
               <a:rPr sz="1150" b="0" i="0">
                 <a:solidFill>
-                  <a:srgbClr val="55607A"/>
+                  <a:srgbClr val="54607A"/>
                 </a:solidFill>
                 <a:latin typeface="Calibri"/>
               </a:rPr>
@@ -17410,7 +17410,7 @@
             <a:avLst/>
           </a:prstGeom>
           <a:solidFill>
-            <a:srgbClr val="FFFFFF"/>
+            <a:srgbClr val="FCFBF8"/>
           </a:solidFill>
           <a:ln>
             <a:noFill/>
@@ -17454,7 +17454,7 @@
             <a:avLst/>
           </a:prstGeom>
           <a:solidFill>
-            <a:srgbClr val="FFFFFF"/>
+            <a:srgbClr val="FCFBF8"/>
           </a:solidFill>
           <a:ln>
             <a:noFill/>
@@ -17498,7 +17498,7 @@
             <a:avLst/>
           </a:prstGeom>
           <a:solidFill>
-            <a:srgbClr val="E4A11B"/>
+            <a:srgbClr val="E6A339"/>
           </a:solidFill>
           <a:ln>
             <a:noFill/>
@@ -17561,9 +17561,9 @@
               </a:spcAft>
             </a:pPr>
             <a:r>
-              <a:rPr sz="1250" b="1" i="0">
-                <a:solidFill>
-                  <a:srgbClr val="2E6E9E"/>
+              <a:rPr sz="1200" b="1" i="0">
+                <a:solidFill>
+                  <a:srgbClr val="3D6A8E"/>
                 </a:solidFill>
                 <a:latin typeface="Calibri"/>
               </a:rPr>
@@ -17608,9 +17608,9 @@
             <a:r>
               <a:rPr sz="2700" b="1" i="0">
                 <a:solidFill>
-                  <a:srgbClr val="0E2A47"/>
-                </a:solidFill>
-                <a:latin typeface="Calibri"/>
+                  <a:srgbClr val="0B2A4A"/>
+                </a:solidFill>
+                <a:latin typeface="Georgia"/>
               </a:rPr>
               <a:t>Ce qu'il faut retenir</a:t>
             </a:r>
@@ -17632,7 +17632,7 @@
             <a:avLst/>
           </a:prstGeom>
           <a:solidFill>
-            <a:srgbClr val="E4A11B"/>
+            <a:srgbClr val="E6A339"/>
           </a:solidFill>
           <a:ln>
             <a:noFill/>
@@ -17678,7 +17678,7 @@
             </a:avLst>
           </a:prstGeom>
           <a:solidFill>
-            <a:srgbClr val="0E2A47"/>
+            <a:srgbClr val="0B2A4A"/>
           </a:solidFill>
           <a:ln>
             <a:noFill/>
@@ -17722,7 +17722,7 @@
             <a:avLst/>
           </a:prstGeom>
           <a:solidFill>
-            <a:srgbClr val="E4A11B"/>
+            <a:srgbClr val="E6A339"/>
           </a:solidFill>
           <a:ln>
             <a:noFill/>
@@ -17787,9 +17787,9 @@
             <a:r>
               <a:rPr sz="1250" b="1" i="0">
                 <a:solidFill>
-                  <a:srgbClr val="E4A11B"/>
-                </a:solidFill>
-                <a:latin typeface="Calibri"/>
+                  <a:srgbClr val="E6A339"/>
+                </a:solidFill>
+                <a:latin typeface="Georgia"/>
               </a:rPr>
               <a:t>LA RÉPONSE</a:t>
             </a:r>
@@ -17876,7 +17876,7 @@
             </a:avLst>
           </a:prstGeom>
           <a:solidFill>
-            <a:srgbClr val="F4F6F9"/>
+            <a:srgbClr val="EDF2F6"/>
           </a:solidFill>
           <a:ln>
             <a:noFill/>
@@ -17941,9 +17941,9 @@
             <a:r>
               <a:rPr sz="1250" b="1" i="0">
                 <a:solidFill>
-                  <a:srgbClr val="0E2A47"/>
-                </a:solidFill>
-                <a:latin typeface="Calibri"/>
+                  <a:srgbClr val="0B2A4A"/>
+                </a:solidFill>
+                <a:latin typeface="Georgia"/>
               </a:rPr>
               <a:t>FACTEURS CLÉS</a:t>
             </a:r>
@@ -17986,7 +17986,7 @@
             <a:r>
               <a:rPr sz="1250" b="1">
                 <a:solidFill>
-                  <a:srgbClr val="E4A11B"/>
+                  <a:srgbClr val="E6A339"/>
                 </a:solidFill>
                 <a:latin typeface="Calibri"/>
               </a:rPr>
@@ -17995,7 +17995,7 @@
             <a:r>
               <a:rPr sz="1250">
                 <a:solidFill>
-                  <a:srgbClr val="1A2033"/>
+                  <a:srgbClr val="18243C"/>
                 </a:solidFill>
                 <a:latin typeface="Calibri"/>
               </a:rPr>
@@ -18017,7 +18017,7 @@
             <a:r>
               <a:rPr sz="1250" b="1">
                 <a:solidFill>
-                  <a:srgbClr val="E4A11B"/>
+                  <a:srgbClr val="E6A339"/>
                 </a:solidFill>
                 <a:latin typeface="Calibri"/>
               </a:rPr>
@@ -18026,7 +18026,7 @@
             <a:r>
               <a:rPr sz="1250">
                 <a:solidFill>
-                  <a:srgbClr val="1A2033"/>
+                  <a:srgbClr val="18243C"/>
                 </a:solidFill>
                 <a:latin typeface="Calibri"/>
               </a:rPr>
@@ -18048,7 +18048,7 @@
             <a:r>
               <a:rPr sz="1250" b="1">
                 <a:solidFill>
-                  <a:srgbClr val="E4A11B"/>
+                  <a:srgbClr val="E6A339"/>
                 </a:solidFill>
                 <a:latin typeface="Calibri"/>
               </a:rPr>
@@ -18057,7 +18057,7 @@
             <a:r>
               <a:rPr sz="1250">
                 <a:solidFill>
-                  <a:srgbClr val="1A2033"/>
+                  <a:srgbClr val="18243C"/>
                 </a:solidFill>
                 <a:latin typeface="Calibri"/>
               </a:rPr>
@@ -18079,7 +18079,7 @@
             <a:r>
               <a:rPr sz="1250" b="1">
                 <a:solidFill>
-                  <a:srgbClr val="E4A11B"/>
+                  <a:srgbClr val="E6A339"/>
                 </a:solidFill>
                 <a:latin typeface="Calibri"/>
               </a:rPr>
@@ -18088,7 +18088,7 @@
             <a:r>
               <a:rPr sz="1250">
                 <a:solidFill>
-                  <a:srgbClr val="1A2033"/>
+                  <a:srgbClr val="18243C"/>
                 </a:solidFill>
                 <a:latin typeface="Calibri"/>
               </a:rPr>
@@ -18114,7 +18114,7 @@
             </a:avLst>
           </a:prstGeom>
           <a:solidFill>
-            <a:srgbClr val="F4F6F9"/>
+            <a:srgbClr val="EDF2F6"/>
           </a:solidFill>
           <a:ln>
             <a:noFill/>
@@ -18181,7 +18181,7 @@
                 <a:solidFill>
                   <a:srgbClr val="A84530"/>
                 </a:solidFill>
-                <a:latin typeface="Calibri"/>
+                <a:latin typeface="Georgia"/>
               </a:rPr>
               <a:t>LIMITES</a:t>
             </a:r>
@@ -18233,7 +18233,7 @@
             <a:r>
               <a:rPr sz="1250">
                 <a:solidFill>
-                  <a:srgbClr val="1A2033"/>
+                  <a:srgbClr val="18243C"/>
                 </a:solidFill>
                 <a:latin typeface="Calibri"/>
               </a:rPr>
@@ -18264,7 +18264,7 @@
             <a:r>
               <a:rPr sz="1250">
                 <a:solidFill>
-                  <a:srgbClr val="1A2033"/>
+                  <a:srgbClr val="18243C"/>
                 </a:solidFill>
                 <a:latin typeface="Calibri"/>
               </a:rPr>
@@ -18295,7 +18295,7 @@
             <a:r>
               <a:rPr sz="1250">
                 <a:solidFill>
-                  <a:srgbClr val="1A2033"/>
+                  <a:srgbClr val="18243C"/>
                 </a:solidFill>
                 <a:latin typeface="Calibri"/>
               </a:rPr>
@@ -18326,7 +18326,7 @@
             <a:r>
               <a:rPr sz="1250">
                 <a:solidFill>
-                  <a:srgbClr val="1A2033"/>
+                  <a:srgbClr val="18243C"/>
                 </a:solidFill>
                 <a:latin typeface="Calibri"/>
               </a:rPr>
@@ -18419,7 +18419,7 @@
                 <a:solidFill>
                   <a:srgbClr val="257448"/>
                 </a:solidFill>
-                <a:latin typeface="Calibri"/>
+                <a:latin typeface="Georgia"/>
               </a:rPr>
               <a:t>OUVERTURE</a:t>
             </a:r>
@@ -18462,7 +18462,7 @@
             <a:r>
               <a:rPr sz="1250" b="0" i="0">
                 <a:solidFill>
-                  <a:srgbClr val="1A2033"/>
+                  <a:srgbClr val="18243C"/>
                 </a:solidFill>
                 <a:latin typeface="Calibri"/>
               </a:rPr>
@@ -18471,7 +18471,7 @@
             <a:r>
               <a:rPr sz="1250" b="1" i="0">
                 <a:solidFill>
-                  <a:srgbClr val="1A2033"/>
+                  <a:srgbClr val="18243C"/>
                 </a:solidFill>
                 <a:latin typeface="Calibri"/>
               </a:rPr>
@@ -18480,7 +18480,7 @@
             <a:r>
               <a:rPr sz="1250" b="0" i="0">
                 <a:solidFill>
-                  <a:srgbClr val="55607A"/>
+                  <a:srgbClr val="54607A"/>
                 </a:solidFill>
                 <a:latin typeface="Calibri"/>
               </a:rPr>
@@ -18612,7 +18612,7 @@
             <a:avLst/>
           </a:prstGeom>
           <a:solidFill>
-            <a:srgbClr val="0E2A47"/>
+            <a:srgbClr val="0B2A4A"/>
           </a:solidFill>
           <a:ln>
             <a:noFill/>
@@ -18656,7 +18656,7 @@
             <a:avLst/>
           </a:prstGeom>
           <a:solidFill>
-            <a:srgbClr val="E4A11B"/>
+            <a:srgbClr val="E6A339"/>
           </a:solidFill>
           <a:ln>
             <a:noFill/>
@@ -18700,7 +18700,7 @@
             <a:avLst/>
           </a:prstGeom>
           <a:solidFill>
-            <a:srgbClr val="E4A11B"/>
+            <a:srgbClr val="E6A339"/>
           </a:solidFill>
           <a:ln>
             <a:noFill/>
@@ -18767,7 +18767,7 @@
                 <a:solidFill>
                   <a:srgbClr val="FFFFFF"/>
                 </a:solidFill>
-                <a:latin typeface="Calibri"/>
+                <a:latin typeface="Georgia"/>
               </a:rPr>
               <a:t>Merci de votre attention</a:t>
             </a:r>
@@ -18834,7 +18834,7 @@
             <a:avLst/>
           </a:prstGeom>
           <a:solidFill>
-            <a:srgbClr val="E4A11B"/>
+            <a:srgbClr val="E6A339"/>
           </a:solidFill>
           <a:ln>
             <a:noFill/>
@@ -18995,7 +18995,7 @@
             <a:avLst/>
           </a:prstGeom>
           <a:solidFill>
-            <a:srgbClr val="0E2A47"/>
+            <a:srgbClr val="0B2A4A"/>
           </a:solidFill>
           <a:ln>
             <a:noFill/>
@@ -19039,7 +19039,7 @@
             <a:avLst/>
           </a:prstGeom>
           <a:solidFill>
-            <a:srgbClr val="E4A11B"/>
+            <a:srgbClr val="E6A339"/>
           </a:solidFill>
           <a:ln>
             <a:noFill/>
@@ -19083,7 +19083,7 @@
             <a:avLst/>
           </a:prstGeom>
           <a:solidFill>
-            <a:srgbClr val="E4A11B"/>
+            <a:srgbClr val="E6A339"/>
           </a:solidFill>
           <a:ln>
             <a:noFill/>
@@ -19150,7 +19150,7 @@
                 <a:solidFill>
                   <a:srgbClr val="24466B"/>
                 </a:solidFill>
-                <a:latin typeface="Calibri"/>
+                <a:latin typeface="Georgia"/>
               </a:rPr>
               <a:t>01</a:t>
             </a:r>
@@ -19195,7 +19195,7 @@
                 <a:solidFill>
                   <a:srgbClr val="FFFFFF"/>
                 </a:solidFill>
-                <a:latin typeface="Calibri"/>
+                <a:latin typeface="Georgia"/>
               </a:rPr>
               <a:t>Contexte &amp; problématique</a:t>
             </a:r>
@@ -19370,7 +19370,7 @@
             <a:avLst/>
           </a:prstGeom>
           <a:solidFill>
-            <a:srgbClr val="FFFFFF"/>
+            <a:srgbClr val="FCFBF8"/>
           </a:solidFill>
           <a:ln>
             <a:noFill/>
@@ -19414,7 +19414,7 @@
             <a:avLst/>
           </a:prstGeom>
           <a:solidFill>
-            <a:srgbClr val="FFFFFF"/>
+            <a:srgbClr val="FCFBF8"/>
           </a:solidFill>
           <a:ln>
             <a:noFill/>
@@ -19458,7 +19458,7 @@
             <a:avLst/>
           </a:prstGeom>
           <a:solidFill>
-            <a:srgbClr val="E4A11B"/>
+            <a:srgbClr val="E6A339"/>
           </a:solidFill>
           <a:ln>
             <a:noFill/>
@@ -19521,9 +19521,9 @@
               </a:spcAft>
             </a:pPr>
             <a:r>
-              <a:rPr sz="1250" b="1" i="0">
-                <a:solidFill>
-                  <a:srgbClr val="2E6E9E"/>
+              <a:rPr sz="1200" b="1" i="0">
+                <a:solidFill>
+                  <a:srgbClr val="3D6A8E"/>
                 </a:solidFill>
                 <a:latin typeface="Calibri"/>
               </a:rPr>
@@ -19568,9 +19568,9 @@
             <a:r>
               <a:rPr sz="2700" b="1" i="0">
                 <a:solidFill>
-                  <a:srgbClr val="0E2A47"/>
-                </a:solidFill>
-                <a:latin typeface="Calibri"/>
+                  <a:srgbClr val="0B2A4A"/>
+                </a:solidFill>
+                <a:latin typeface="Georgia"/>
               </a:rPr>
               <a:t>Une bascule technologique, un angle mort : la PME</a:t>
             </a:r>
@@ -19592,7 +19592,7 @@
             <a:avLst/>
           </a:prstGeom>
           <a:solidFill>
-            <a:srgbClr val="E4A11B"/>
+            <a:srgbClr val="E6A339"/>
           </a:solidFill>
           <a:ln>
             <a:noFill/>
@@ -19638,7 +19638,7 @@
             </a:avLst>
           </a:prstGeom>
           <a:solidFill>
-            <a:srgbClr val="EDF1F6"/>
+            <a:srgbClr val="F7F2E8"/>
           </a:solidFill>
           <a:ln>
             <a:noFill/>
@@ -19703,9 +19703,9 @@
             <a:r>
               <a:rPr sz="1300" b="1" i="0">
                 <a:solidFill>
-                  <a:srgbClr val="2E6E9E"/>
-                </a:solidFill>
-                <a:latin typeface="Calibri"/>
+                  <a:srgbClr val="3D6A8E"/>
+                </a:solidFill>
+                <a:latin typeface="Georgia"/>
               </a:rPr>
               <a:t>UNE VAGUE TECHNOLOGIQUE INÉDITE</a:t>
             </a:r>
@@ -19748,7 +19748,7 @@
             <a:r>
               <a:rPr sz="1400" b="1">
                 <a:solidFill>
-                  <a:srgbClr val="E4A11B"/>
+                  <a:srgbClr val="E6A339"/>
                 </a:solidFill>
                 <a:latin typeface="Calibri"/>
               </a:rPr>
@@ -19757,7 +19757,7 @@
             <a:r>
               <a:rPr sz="1400" b="1">
                 <a:solidFill>
-                  <a:srgbClr val="1A2033"/>
+                  <a:srgbClr val="18243C"/>
                 </a:solidFill>
                 <a:latin typeface="Calibri"/>
               </a:rPr>
@@ -19766,7 +19766,7 @@
             <a:r>
               <a:rPr sz="1400" b="0">
                 <a:solidFill>
-                  <a:srgbClr val="55607A"/>
+                  <a:srgbClr val="54607A"/>
                 </a:solidFill>
                 <a:latin typeface="Calibri"/>
               </a:rPr>
@@ -19788,7 +19788,7 @@
             <a:r>
               <a:rPr sz="1400" b="1">
                 <a:solidFill>
-                  <a:srgbClr val="E4A11B"/>
+                  <a:srgbClr val="E6A339"/>
                 </a:solidFill>
                 <a:latin typeface="Calibri"/>
               </a:rPr>
@@ -19797,7 +19797,7 @@
             <a:r>
               <a:rPr sz="1400" b="1">
                 <a:solidFill>
-                  <a:srgbClr val="1A2033"/>
+                  <a:srgbClr val="18243C"/>
                 </a:solidFill>
                 <a:latin typeface="Calibri"/>
               </a:rPr>
@@ -19806,7 +19806,7 @@
             <a:r>
               <a:rPr sz="1400" b="0">
                 <a:solidFill>
-                  <a:srgbClr val="55607A"/>
+                  <a:srgbClr val="54607A"/>
                 </a:solidFill>
                 <a:latin typeface="Calibri"/>
               </a:rPr>
@@ -19828,7 +19828,7 @@
             <a:r>
               <a:rPr sz="1400" b="1">
                 <a:solidFill>
-                  <a:srgbClr val="E4A11B"/>
+                  <a:srgbClr val="E6A339"/>
                 </a:solidFill>
                 <a:latin typeface="Calibri"/>
               </a:rPr>
@@ -19837,7 +19837,7 @@
             <a:r>
               <a:rPr sz="1400" b="1">
                 <a:solidFill>
-                  <a:srgbClr val="1A2033"/>
+                  <a:srgbClr val="18243C"/>
                 </a:solidFill>
                 <a:latin typeface="Calibri"/>
               </a:rPr>
@@ -19846,7 +19846,7 @@
             <a:r>
               <a:rPr sz="1400" b="0">
                 <a:solidFill>
-                  <a:srgbClr val="55607A"/>
+                  <a:srgbClr val="54607A"/>
                 </a:solidFill>
                 <a:latin typeface="Calibri"/>
               </a:rPr>
@@ -19868,7 +19868,7 @@
             <a:r>
               <a:rPr sz="1400" b="1">
                 <a:solidFill>
-                  <a:srgbClr val="E4A11B"/>
+                  <a:srgbClr val="E6A339"/>
                 </a:solidFill>
                 <a:latin typeface="Calibri"/>
               </a:rPr>
@@ -19877,7 +19877,7 @@
             <a:r>
               <a:rPr sz="1400" b="1">
                 <a:solidFill>
-                  <a:srgbClr val="1A2033"/>
+                  <a:srgbClr val="18243C"/>
                 </a:solidFill>
                 <a:latin typeface="Calibri"/>
               </a:rPr>
@@ -19886,7 +19886,7 @@
             <a:r>
               <a:rPr sz="1400" b="0">
                 <a:solidFill>
-                  <a:srgbClr val="55607A"/>
+                  <a:srgbClr val="54607A"/>
                 </a:solidFill>
                 <a:latin typeface="Calibri"/>
               </a:rPr>
@@ -19916,7 +19916,7 @@
           </a:solidFill>
           <a:ln w="12700">
             <a:solidFill>
-              <a:srgbClr val="D7DDE6"/>
+              <a:srgbClr val="E6DFD3"/>
             </a:solidFill>
           </a:ln>
           <a:effectLst/>
@@ -19958,7 +19958,7 @@
             <a:avLst/>
           </a:prstGeom>
           <a:solidFill>
-            <a:srgbClr val="E4A11B"/>
+            <a:srgbClr val="E6A339"/>
           </a:solidFill>
           <a:ln>
             <a:noFill/>
@@ -20023,9 +20023,9 @@
             <a:r>
               <a:rPr sz="1300" b="1" i="0">
                 <a:solidFill>
-                  <a:srgbClr val="C6860E"/>
-                </a:solidFill>
-                <a:latin typeface="Calibri"/>
+                  <a:srgbClr val="AF7112"/>
+                </a:solidFill>
+                <a:latin typeface="Georgia"/>
               </a:rPr>
               <a:t>MAIS LA PME EST UN CAS À PART</a:t>
             </a:r>
@@ -20068,7 +20068,7 @@
             <a:r>
               <a:rPr sz="1400" b="1">
                 <a:solidFill>
-                  <a:srgbClr val="E4A11B"/>
+                  <a:srgbClr val="E6A339"/>
                 </a:solidFill>
                 <a:latin typeface="Calibri"/>
               </a:rPr>
@@ -20077,7 +20077,7 @@
             <a:r>
               <a:rPr sz="1400" b="1">
                 <a:solidFill>
-                  <a:srgbClr val="1A2033"/>
+                  <a:srgbClr val="18243C"/>
                 </a:solidFill>
                 <a:latin typeface="Calibri"/>
               </a:rPr>
@@ -20086,7 +20086,7 @@
             <a:r>
               <a:rPr sz="1400" b="0">
                 <a:solidFill>
-                  <a:srgbClr val="55607A"/>
+                  <a:srgbClr val="54607A"/>
                 </a:solidFill>
                 <a:latin typeface="Calibri"/>
               </a:rPr>
@@ -20108,7 +20108,7 @@
             <a:r>
               <a:rPr sz="1400" b="1">
                 <a:solidFill>
-                  <a:srgbClr val="E4A11B"/>
+                  <a:srgbClr val="E6A339"/>
                 </a:solidFill>
                 <a:latin typeface="Calibri"/>
               </a:rPr>
@@ -20117,7 +20117,7 @@
             <a:r>
               <a:rPr sz="1400" b="1">
                 <a:solidFill>
-                  <a:srgbClr val="1A2033"/>
+                  <a:srgbClr val="18243C"/>
                 </a:solidFill>
                 <a:latin typeface="Calibri"/>
               </a:rPr>
@@ -20126,7 +20126,7 @@
             <a:r>
               <a:rPr sz="1400" b="0">
                 <a:solidFill>
-                  <a:srgbClr val="55607A"/>
+                  <a:srgbClr val="54607A"/>
                 </a:solidFill>
                 <a:latin typeface="Calibri"/>
               </a:rPr>
@@ -20148,7 +20148,7 @@
             <a:r>
               <a:rPr sz="1400" b="1">
                 <a:solidFill>
-                  <a:srgbClr val="E4A11B"/>
+                  <a:srgbClr val="E6A339"/>
                 </a:solidFill>
                 <a:latin typeface="Calibri"/>
               </a:rPr>
@@ -20157,7 +20157,7 @@
             <a:r>
               <a:rPr sz="1400" b="1">
                 <a:solidFill>
-                  <a:srgbClr val="1A2033"/>
+                  <a:srgbClr val="18243C"/>
                 </a:solidFill>
                 <a:latin typeface="Calibri"/>
               </a:rPr>
@@ -20166,7 +20166,7 @@
             <a:r>
               <a:rPr sz="1400" b="0">
                 <a:solidFill>
-                  <a:srgbClr val="55607A"/>
+                  <a:srgbClr val="54607A"/>
                 </a:solidFill>
                 <a:latin typeface="Calibri"/>
               </a:rPr>
@@ -20188,7 +20188,7 @@
             <a:r>
               <a:rPr sz="1400" b="1">
                 <a:solidFill>
-                  <a:srgbClr val="E4A11B"/>
+                  <a:srgbClr val="E6A339"/>
                 </a:solidFill>
                 <a:latin typeface="Calibri"/>
               </a:rPr>
@@ -20197,7 +20197,7 @@
             <a:r>
               <a:rPr sz="1400" b="1">
                 <a:solidFill>
-                  <a:srgbClr val="1A2033"/>
+                  <a:srgbClr val="18243C"/>
                 </a:solidFill>
                 <a:latin typeface="Calibri"/>
               </a:rPr>
@@ -20206,7 +20206,7 @@
             <a:r>
               <a:rPr sz="1400" b="0">
                 <a:solidFill>
-                  <a:srgbClr val="55607A"/>
+                  <a:srgbClr val="54607A"/>
                 </a:solidFill>
                 <a:latin typeface="Calibri"/>
               </a:rPr>
@@ -20338,7 +20338,7 @@
             <a:avLst/>
           </a:prstGeom>
           <a:solidFill>
-            <a:srgbClr val="FFFFFF"/>
+            <a:srgbClr val="FCFBF8"/>
           </a:solidFill>
           <a:ln>
             <a:noFill/>
@@ -20382,7 +20382,7 @@
             <a:avLst/>
           </a:prstGeom>
           <a:solidFill>
-            <a:srgbClr val="FFFFFF"/>
+            <a:srgbClr val="FCFBF8"/>
           </a:solidFill>
           <a:ln>
             <a:noFill/>
@@ -20426,7 +20426,7 @@
             <a:avLst/>
           </a:prstGeom>
           <a:solidFill>
-            <a:srgbClr val="E4A11B"/>
+            <a:srgbClr val="E6A339"/>
           </a:solidFill>
           <a:ln>
             <a:noFill/>
@@ -20489,9 +20489,9 @@
               </a:spcAft>
             </a:pPr>
             <a:r>
-              <a:rPr sz="1250" b="1" i="0">
-                <a:solidFill>
-                  <a:srgbClr val="2E6E9E"/>
+              <a:rPr sz="1200" b="1" i="0">
+                <a:solidFill>
+                  <a:srgbClr val="3D6A8E"/>
                 </a:solidFill>
                 <a:latin typeface="Calibri"/>
               </a:rPr>
@@ -20536,9 +20536,9 @@
             <a:r>
               <a:rPr sz="2700" b="1" i="0">
                 <a:solidFill>
-                  <a:srgbClr val="0E2A47"/>
-                </a:solidFill>
-                <a:latin typeface="Calibri"/>
+                  <a:srgbClr val="0B2A4A"/>
+                </a:solidFill>
+                <a:latin typeface="Georgia"/>
               </a:rPr>
               <a:t>Arla Groupe : un usage réel de l'IA, mais non encadré</a:t>
             </a:r>
@@ -20560,7 +20560,7 @@
             <a:avLst/>
           </a:prstGeom>
           <a:solidFill>
-            <a:srgbClr val="E4A11B"/>
+            <a:srgbClr val="E6A339"/>
           </a:solidFill>
           <a:ln>
             <a:noFill/>
@@ -20610,7 +20610,7 @@
           </a:solidFill>
           <a:ln w="12700">
             <a:solidFill>
-              <a:srgbClr val="D7DDE6"/>
+              <a:srgbClr val="E6DFD3"/>
             </a:solidFill>
           </a:ln>
           <a:effectLst/>
@@ -20652,7 +20652,7 @@
             <a:avLst/>
           </a:prstGeom>
           <a:solidFill>
-            <a:srgbClr val="2E6E9E"/>
+            <a:srgbClr val="3D6A8E"/>
           </a:solidFill>
           <a:ln>
             <a:noFill/>
@@ -20717,9 +20717,9 @@
             <a:r>
               <a:rPr sz="1300" b="1" i="0">
                 <a:solidFill>
-                  <a:srgbClr val="2E6E9E"/>
-                </a:solidFill>
-                <a:latin typeface="Calibri"/>
+                  <a:srgbClr val="3D6A8E"/>
+                </a:solidFill>
+                <a:latin typeface="Georgia"/>
               </a:rPr>
               <a:t>LE TERRAIN — ARLA GROUPE</a:t>
             </a:r>
@@ -20762,7 +20762,7 @@
             <a:r>
               <a:rPr sz="1350" b="1">
                 <a:solidFill>
-                  <a:srgbClr val="E4A11B"/>
+                  <a:srgbClr val="E6A339"/>
                 </a:solidFill>
                 <a:latin typeface="Calibri"/>
               </a:rPr>
@@ -20771,7 +20771,7 @@
             <a:r>
               <a:rPr sz="1350" b="1">
                 <a:solidFill>
-                  <a:srgbClr val="1A2033"/>
+                  <a:srgbClr val="18243C"/>
                 </a:solidFill>
                 <a:latin typeface="Calibri"/>
               </a:rPr>
@@ -20780,7 +20780,7 @@
             <a:r>
               <a:rPr sz="1350" b="0">
                 <a:solidFill>
-                  <a:srgbClr val="55607A"/>
+                  <a:srgbClr val="54607A"/>
                 </a:solidFill>
                 <a:latin typeface="Calibri"/>
               </a:rPr>
@@ -20802,7 +20802,7 @@
             <a:r>
               <a:rPr sz="1350" b="1">
                 <a:solidFill>
-                  <a:srgbClr val="E4A11B"/>
+                  <a:srgbClr val="E6A339"/>
                 </a:solidFill>
                 <a:latin typeface="Calibri"/>
               </a:rPr>
@@ -20811,7 +20811,7 @@
             <a:r>
               <a:rPr sz="1350" b="1">
                 <a:solidFill>
-                  <a:srgbClr val="1A2033"/>
+                  <a:srgbClr val="18243C"/>
                 </a:solidFill>
                 <a:latin typeface="Calibri"/>
               </a:rPr>
@@ -20820,7 +20820,7 @@
             <a:r>
               <a:rPr sz="1350" b="0">
                 <a:solidFill>
-                  <a:srgbClr val="55607A"/>
+                  <a:srgbClr val="54607A"/>
                 </a:solidFill>
                 <a:latin typeface="Calibri"/>
               </a:rPr>
@@ -20842,7 +20842,7 @@
             <a:r>
               <a:rPr sz="1350" b="1">
                 <a:solidFill>
-                  <a:srgbClr val="E4A11B"/>
+                  <a:srgbClr val="E6A339"/>
                 </a:solidFill>
                 <a:latin typeface="Calibri"/>
               </a:rPr>
@@ -20851,7 +20851,7 @@
             <a:r>
               <a:rPr sz="1350" b="1">
                 <a:solidFill>
-                  <a:srgbClr val="1A2033"/>
+                  <a:srgbClr val="18243C"/>
                 </a:solidFill>
                 <a:latin typeface="Calibri"/>
               </a:rPr>
@@ -20860,7 +20860,7 @@
             <a:r>
               <a:rPr sz="1350" b="0">
                 <a:solidFill>
-                  <a:srgbClr val="55607A"/>
+                  <a:srgbClr val="54607A"/>
                 </a:solidFill>
                 <a:latin typeface="Calibri"/>
               </a:rPr>
@@ -20882,7 +20882,7 @@
             <a:r>
               <a:rPr sz="1350" b="1">
                 <a:solidFill>
-                  <a:srgbClr val="E4A11B"/>
+                  <a:srgbClr val="E6A339"/>
                 </a:solidFill>
                 <a:latin typeface="Calibri"/>
               </a:rPr>
@@ -20891,7 +20891,7 @@
             <a:r>
               <a:rPr sz="1350" b="1">
                 <a:solidFill>
-                  <a:srgbClr val="1A2033"/>
+                  <a:srgbClr val="18243C"/>
                 </a:solidFill>
                 <a:latin typeface="Calibri"/>
               </a:rPr>
@@ -20900,7 +20900,7 @@
             <a:r>
               <a:rPr sz="1350" b="0">
                 <a:solidFill>
-                  <a:srgbClr val="55607A"/>
+                  <a:srgbClr val="54607A"/>
                 </a:solidFill>
                 <a:latin typeface="Calibri"/>
               </a:rPr>
@@ -20926,7 +20926,7 @@
             </a:avLst>
           </a:prstGeom>
           <a:solidFill>
-            <a:srgbClr val="0E2A47"/>
+            <a:srgbClr val="0B2A4A"/>
           </a:solidFill>
           <a:ln>
             <a:noFill/>
@@ -20970,7 +20970,7 @@
             <a:avLst/>
           </a:prstGeom>
           <a:solidFill>
-            <a:srgbClr val="E4A11B"/>
+            <a:srgbClr val="E6A339"/>
           </a:solidFill>
           <a:ln>
             <a:noFill/>
@@ -21035,9 +21035,9 @@
             <a:r>
               <a:rPr sz="1300" b="1" i="0">
                 <a:solidFill>
-                  <a:srgbClr val="E4A11B"/>
-                </a:solidFill>
-                <a:latin typeface="Calibri"/>
+                  <a:srgbClr val="E6A339"/>
+                </a:solidFill>
+                <a:latin typeface="Georgia"/>
               </a:rPr>
               <a:t>PROBLÉMATIQUE</a:t>
             </a:r>
@@ -21082,7 +21082,7 @@
                 <a:solidFill>
                   <a:srgbClr val="FFFFFF"/>
                 </a:solidFill>
-                <a:latin typeface="Calibri"/>
+                <a:latin typeface="Georgia"/>
               </a:rPr>
               <a:t>« Comment les PME peuvent-elles intégrer l'IA et les technologies numériques tout en tenant compte de leurs ressources limitées, de leur structure organisationnelle et de leur culture d'entreprise ? »</a:t>
             </a:r>
@@ -21104,7 +21104,7 @@
             <a:avLst/>
           </a:prstGeom>
           <a:solidFill>
-            <a:srgbClr val="2E6E9E"/>
+            <a:srgbClr val="3D6A8E"/>
           </a:solidFill>
           <a:ln>
             <a:noFill/>
@@ -21171,7 +21171,7 @@
                 <a:solidFill>
                   <a:srgbClr val="FFFFFF"/>
                 </a:solidFill>
-                <a:latin typeface="Calibri"/>
+                <a:latin typeface="Georgia"/>
               </a:rPr>
               <a:t>QR1</a:t>
             </a:r>
@@ -21214,7 +21214,7 @@
             <a:r>
               <a:rPr sz="1250" b="0" i="0">
                 <a:solidFill>
-                  <a:srgbClr val="1A2033"/>
+                  <a:srgbClr val="18243C"/>
                 </a:solidFill>
                 <a:latin typeface="Calibri"/>
               </a:rPr>
@@ -21238,7 +21238,7 @@
             <a:avLst/>
           </a:prstGeom>
           <a:solidFill>
-            <a:srgbClr val="2E6E9E"/>
+            <a:srgbClr val="3D6A8E"/>
           </a:solidFill>
           <a:ln>
             <a:noFill/>
@@ -21305,7 +21305,7 @@
                 <a:solidFill>
                   <a:srgbClr val="FFFFFF"/>
                 </a:solidFill>
-                <a:latin typeface="Calibri"/>
+                <a:latin typeface="Georgia"/>
               </a:rPr>
               <a:t>QR2</a:t>
             </a:r>
@@ -21348,7 +21348,7 @@
             <a:r>
               <a:rPr sz="1250" b="0" i="0">
                 <a:solidFill>
-                  <a:srgbClr val="1A2033"/>
+                  <a:srgbClr val="18243C"/>
                 </a:solidFill>
                 <a:latin typeface="Calibri"/>
               </a:rPr>
@@ -21372,7 +21372,7 @@
             <a:avLst/>
           </a:prstGeom>
           <a:solidFill>
-            <a:srgbClr val="2E6E9E"/>
+            <a:srgbClr val="3D6A8E"/>
           </a:solidFill>
           <a:ln>
             <a:noFill/>
@@ -21439,7 +21439,7 @@
                 <a:solidFill>
                   <a:srgbClr val="FFFFFF"/>
                 </a:solidFill>
-                <a:latin typeface="Calibri"/>
+                <a:latin typeface="Georgia"/>
               </a:rPr>
               <a:t>QR3</a:t>
             </a:r>
@@ -21482,7 +21482,7 @@
             <a:r>
               <a:rPr sz="1250" b="0" i="0">
                 <a:solidFill>
-                  <a:srgbClr val="1A2033"/>
+                  <a:srgbClr val="18243C"/>
                 </a:solidFill>
                 <a:latin typeface="Calibri"/>
               </a:rPr>
@@ -21614,7 +21614,7 @@
             <a:avLst/>
           </a:prstGeom>
           <a:solidFill>
-            <a:srgbClr val="0E2A47"/>
+            <a:srgbClr val="0B2A4A"/>
           </a:solidFill>
           <a:ln>
             <a:noFill/>
@@ -21658,7 +21658,7 @@
             <a:avLst/>
           </a:prstGeom>
           <a:solidFill>
-            <a:srgbClr val="E4A11B"/>
+            <a:srgbClr val="E6A339"/>
           </a:solidFill>
           <a:ln>
             <a:noFill/>
@@ -21702,7 +21702,7 @@
             <a:avLst/>
           </a:prstGeom>
           <a:solidFill>
-            <a:srgbClr val="E4A11B"/>
+            <a:srgbClr val="E6A339"/>
           </a:solidFill>
           <a:ln>
             <a:noFill/>
@@ -21769,7 +21769,7 @@
                 <a:solidFill>
                   <a:srgbClr val="24466B"/>
                 </a:solidFill>
-                <a:latin typeface="Calibri"/>
+                <a:latin typeface="Georgia"/>
               </a:rPr>
               <a:t>02</a:t>
             </a:r>
@@ -21814,7 +21814,7 @@
                 <a:solidFill>
                   <a:srgbClr val="FFFFFF"/>
                 </a:solidFill>
-                <a:latin typeface="Calibri"/>
+                <a:latin typeface="Georgia"/>
               </a:rPr>
               <a:t>Cadre théorique &amp; propositions</a:t>
             </a:r>
@@ -21989,7 +21989,7 @@
             <a:avLst/>
           </a:prstGeom>
           <a:solidFill>
-            <a:srgbClr val="FFFFFF"/>
+            <a:srgbClr val="FCFBF8"/>
           </a:solidFill>
           <a:ln>
             <a:noFill/>
@@ -22033,7 +22033,7 @@
             <a:avLst/>
           </a:prstGeom>
           <a:solidFill>
-            <a:srgbClr val="FFFFFF"/>
+            <a:srgbClr val="FCFBF8"/>
           </a:solidFill>
           <a:ln>
             <a:noFill/>
@@ -22077,7 +22077,7 @@
             <a:avLst/>
           </a:prstGeom>
           <a:solidFill>
-            <a:srgbClr val="E4A11B"/>
+            <a:srgbClr val="E6A339"/>
           </a:solidFill>
           <a:ln>
             <a:noFill/>
@@ -22140,9 +22140,9 @@
               </a:spcAft>
             </a:pPr>
             <a:r>
-              <a:rPr sz="1250" b="1" i="0">
-                <a:solidFill>
-                  <a:srgbClr val="2E6E9E"/>
+              <a:rPr sz="1200" b="1" i="0">
+                <a:solidFill>
+                  <a:srgbClr val="3D6A8E"/>
                 </a:solidFill>
                 <a:latin typeface="Calibri"/>
               </a:rPr>
@@ -22187,9 +22187,9 @@
             <a:r>
               <a:rPr sz="2700" b="1" i="0">
                 <a:solidFill>
-                  <a:srgbClr val="0E2A47"/>
-                </a:solidFill>
-                <a:latin typeface="Calibri"/>
+                  <a:srgbClr val="0B2A4A"/>
+                </a:solidFill>
+                <a:latin typeface="Georgia"/>
               </a:rPr>
               <a:t>La PME : un objet organisationnel spécifique</a:t>
             </a:r>
@@ -22211,7 +22211,7 @@
             <a:avLst/>
           </a:prstGeom>
           <a:solidFill>
-            <a:srgbClr val="E4A11B"/>
+            <a:srgbClr val="E6A339"/>
           </a:solidFill>
           <a:ln>
             <a:noFill/>
@@ -22261,7 +22261,7 @@
           </a:solidFill>
           <a:ln w="12700">
             <a:solidFill>
-              <a:srgbClr val="D7DDE6"/>
+              <a:srgbClr val="E6DFD3"/>
             </a:solidFill>
           </a:ln>
           <a:effectLst/>
@@ -22303,7 +22303,7 @@
             <a:avLst/>
           </a:prstGeom>
           <a:solidFill>
-            <a:srgbClr val="2E6E9E"/>
+            <a:srgbClr val="3D6A8E"/>
           </a:solidFill>
           <a:ln>
             <a:noFill/>
@@ -22347,7 +22347,7 @@
             <a:avLst/>
           </a:prstGeom>
           <a:solidFill>
-            <a:srgbClr val="2E6E9E"/>
+            <a:srgbClr val="3D6A8E"/>
           </a:solidFill>
           <a:ln>
             <a:noFill/>
@@ -22414,7 +22414,7 @@
                 <a:solidFill>
                   <a:srgbClr val="FFFFFF"/>
                 </a:solidFill>
-                <a:latin typeface="Calibri"/>
+                <a:latin typeface="Georgia"/>
               </a:rPr>
               <a:t>DÉFINITION</a:t>
             </a:r>
@@ -22457,7 +22457,7 @@
             <a:r>
               <a:rPr sz="1250" b="1">
                 <a:solidFill>
-                  <a:srgbClr val="2E6E9E"/>
+                  <a:srgbClr val="3D6A8E"/>
                 </a:solidFill>
                 <a:latin typeface="Calibri"/>
               </a:rPr>
@@ -22466,7 +22466,7 @@
             <a:r>
               <a:rPr sz="1250" b="1">
                 <a:solidFill>
-                  <a:srgbClr val="1A2033"/>
+                  <a:srgbClr val="18243C"/>
                 </a:solidFill>
                 <a:latin typeface="Calibri"/>
               </a:rPr>
@@ -22475,7 +22475,7 @@
             <a:r>
               <a:rPr sz="1250" b="0">
                 <a:solidFill>
-                  <a:srgbClr val="55607A"/>
+                  <a:srgbClr val="54607A"/>
                 </a:solidFill>
                 <a:latin typeface="Calibri"/>
               </a:rPr>
@@ -22497,7 +22497,7 @@
             <a:r>
               <a:rPr sz="1250" b="1">
                 <a:solidFill>
-                  <a:srgbClr val="2E6E9E"/>
+                  <a:srgbClr val="3D6A8E"/>
                 </a:solidFill>
                 <a:latin typeface="Calibri"/>
               </a:rPr>
@@ -22506,7 +22506,7 @@
             <a:r>
               <a:rPr sz="1250" b="1">
                 <a:solidFill>
-                  <a:srgbClr val="1A2033"/>
+                  <a:srgbClr val="18243C"/>
                 </a:solidFill>
                 <a:latin typeface="Calibri"/>
               </a:rPr>
@@ -22515,7 +22515,7 @@
             <a:r>
               <a:rPr sz="1250" b="0">
                 <a:solidFill>
-                  <a:srgbClr val="55607A"/>
+                  <a:srgbClr val="54607A"/>
                 </a:solidFill>
                 <a:latin typeface="Calibri"/>
               </a:rPr>
@@ -22545,7 +22545,7 @@
           </a:solidFill>
           <a:ln w="12700">
             <a:solidFill>
-              <a:srgbClr val="D7DDE6"/>
+              <a:srgbClr val="E6DFD3"/>
             </a:solidFill>
           </a:ln>
           <a:effectLst/>
@@ -22587,7 +22587,7 @@
             <a:avLst/>
           </a:prstGeom>
           <a:solidFill>
-            <a:srgbClr val="E4A11B"/>
+            <a:srgbClr val="E6A339"/>
           </a:solidFill>
           <a:ln>
             <a:noFill/>
@@ -22631,7 +22631,7 @@
             <a:avLst/>
           </a:prstGeom>
           <a:solidFill>
-            <a:srgbClr val="E4A11B"/>
+            <a:srgbClr val="E6A339"/>
           </a:solidFill>
           <a:ln>
             <a:noFill/>
@@ -22698,7 +22698,7 @@
                 <a:solidFill>
                   <a:srgbClr val="FFFFFF"/>
                 </a:solidFill>
-                <a:latin typeface="Calibri"/>
+                <a:latin typeface="Georgia"/>
               </a:rPr>
               <a:t>PROXIMITÉ</a:t>
             </a:r>
@@ -22741,7 +22741,7 @@
             <a:r>
               <a:rPr sz="1250" b="1">
                 <a:solidFill>
-                  <a:srgbClr val="E4A11B"/>
+                  <a:srgbClr val="E6A339"/>
                 </a:solidFill>
                 <a:latin typeface="Calibri"/>
               </a:rPr>
@@ -22750,7 +22750,7 @@
             <a:r>
               <a:rPr sz="1250" b="1">
                 <a:solidFill>
-                  <a:srgbClr val="1A2033"/>
+                  <a:srgbClr val="18243C"/>
                 </a:solidFill>
                 <a:latin typeface="Calibri"/>
               </a:rPr>
@@ -22759,7 +22759,7 @@
             <a:r>
               <a:rPr sz="1250" b="0">
                 <a:solidFill>
-                  <a:srgbClr val="55607A"/>
+                  <a:srgbClr val="54607A"/>
                 </a:solidFill>
                 <a:latin typeface="Calibri"/>
               </a:rPr>
@@ -22781,7 +22781,7 @@
             <a:r>
               <a:rPr sz="1250" b="1">
                 <a:solidFill>
-                  <a:srgbClr val="E4A11B"/>
+                  <a:srgbClr val="E6A339"/>
                 </a:solidFill>
                 <a:latin typeface="Calibri"/>
               </a:rPr>
@@ -22790,7 +22790,7 @@
             <a:r>
               <a:rPr sz="1250" b="1">
                 <a:solidFill>
-                  <a:srgbClr val="1A2033"/>
+                  <a:srgbClr val="18243C"/>
                 </a:solidFill>
                 <a:latin typeface="Calibri"/>
               </a:rPr>
@@ -22799,7 +22799,7 @@
             <a:r>
               <a:rPr sz="1250" b="0">
                 <a:solidFill>
-                  <a:srgbClr val="55607A"/>
+                  <a:srgbClr val="54607A"/>
                 </a:solidFill>
                 <a:latin typeface="Calibri"/>
               </a:rPr>
@@ -22829,7 +22829,7 @@
           </a:solidFill>
           <a:ln w="12700">
             <a:solidFill>
-              <a:srgbClr val="D7DDE6"/>
+              <a:srgbClr val="E6DFD3"/>
             </a:solidFill>
           </a:ln>
           <a:effectLst/>
@@ -22871,7 +22871,7 @@
             <a:avLst/>
           </a:prstGeom>
           <a:solidFill>
-            <a:srgbClr val="163A5F"/>
+            <a:srgbClr val="123A61"/>
           </a:solidFill>
           <a:ln>
             <a:noFill/>
@@ -22915,7 +22915,7 @@
             <a:avLst/>
           </a:prstGeom>
           <a:solidFill>
-            <a:srgbClr val="163A5F"/>
+            <a:srgbClr val="123A61"/>
           </a:solidFill>
           <a:ln>
             <a:noFill/>
@@ -22982,7 +22982,7 @@
                 <a:solidFill>
                   <a:srgbClr val="FFFFFF"/>
                 </a:solidFill>
-                <a:latin typeface="Calibri"/>
+                <a:latin typeface="Georgia"/>
               </a:rPr>
               <a:t>CULTURE &amp; TRADITIONS</a:t>
             </a:r>
@@ -23025,7 +23025,7 @@
             <a:r>
               <a:rPr sz="1250" b="1">
                 <a:solidFill>
-                  <a:srgbClr val="163A5F"/>
+                  <a:srgbClr val="123A61"/>
                 </a:solidFill>
                 <a:latin typeface="Calibri"/>
               </a:rPr>
@@ -23034,7 +23034,7 @@
             <a:r>
               <a:rPr sz="1250" b="1">
                 <a:solidFill>
-                  <a:srgbClr val="1A2033"/>
+                  <a:srgbClr val="18243C"/>
                 </a:solidFill>
                 <a:latin typeface="Calibri"/>
               </a:rPr>
@@ -23043,7 +23043,7 @@
             <a:r>
               <a:rPr sz="1250" b="0">
                 <a:solidFill>
-                  <a:srgbClr val="55607A"/>
+                  <a:srgbClr val="54607A"/>
                 </a:solidFill>
                 <a:latin typeface="Calibri"/>
               </a:rPr>
@@ -23065,7 +23065,7 @@
             <a:r>
               <a:rPr sz="1250" b="1">
                 <a:solidFill>
-                  <a:srgbClr val="163A5F"/>
+                  <a:srgbClr val="123A61"/>
                 </a:solidFill>
                 <a:latin typeface="Calibri"/>
               </a:rPr>
@@ -23074,7 +23074,7 @@
             <a:r>
               <a:rPr sz="1250" b="1">
                 <a:solidFill>
-                  <a:srgbClr val="1A2033"/>
+                  <a:srgbClr val="18243C"/>
                 </a:solidFill>
                 <a:latin typeface="Calibri"/>
               </a:rPr>
@@ -23083,7 +23083,7 @@
             <a:r>
               <a:rPr sz="1250" b="0">
                 <a:solidFill>
-                  <a:srgbClr val="55607A"/>
+                  <a:srgbClr val="54607A"/>
                 </a:solidFill>
                 <a:latin typeface="Calibri"/>
               </a:rPr>
@@ -23107,7 +23107,7 @@
             <a:avLst/>
           </a:prstGeom>
           <a:solidFill>
-            <a:srgbClr val="F4F6F9"/>
+            <a:srgbClr val="EDF2F6"/>
           </a:solidFill>
           <a:ln>
             <a:noFill/>
@@ -23151,7 +23151,7 @@
             <a:avLst/>
           </a:prstGeom>
           <a:solidFill>
-            <a:srgbClr val="E4A11B"/>
+            <a:srgbClr val="E6A339"/>
           </a:solidFill>
           <a:ln>
             <a:noFill/>
@@ -23216,9 +23216,9 @@
             <a:r>
               <a:rPr sz="1250" b="1" i="0">
                 <a:solidFill>
-                  <a:srgbClr val="C6860E"/>
-                </a:solidFill>
-                <a:latin typeface="Calibri"/>
+                  <a:srgbClr val="AF7112"/>
+                </a:solidFill>
+                <a:latin typeface="Georgia"/>
               </a:rPr>
               <a:t>PROPOSITION 1</a:t>
             </a:r>
@@ -23261,7 +23261,7 @@
             <a:r>
               <a:rPr sz="1350" b="0" i="1">
                 <a:solidFill>
-                  <a:srgbClr val="1A2033"/>
+                  <a:srgbClr val="18243C"/>
                 </a:solidFill>
                 <a:latin typeface="Calibri"/>
               </a:rPr>
@@ -23393,7 +23393,7 @@
             <a:avLst/>
           </a:prstGeom>
           <a:solidFill>
-            <a:srgbClr val="FFFFFF"/>
+            <a:srgbClr val="FCFBF8"/>
           </a:solidFill>
           <a:ln>
             <a:noFill/>
@@ -23437,7 +23437,7 @@
             <a:avLst/>
           </a:prstGeom>
           <a:solidFill>
-            <a:srgbClr val="FFFFFF"/>
+            <a:srgbClr val="FCFBF8"/>
           </a:solidFill>
           <a:ln>
             <a:noFill/>
@@ -23481,7 +23481,7 @@
             <a:avLst/>
           </a:prstGeom>
           <a:solidFill>
-            <a:srgbClr val="E4A11B"/>
+            <a:srgbClr val="E6A339"/>
           </a:solidFill>
           <a:ln>
             <a:noFill/>
@@ -23544,9 +23544,9 @@
               </a:spcAft>
             </a:pPr>
             <a:r>
-              <a:rPr sz="1250" b="1" i="0">
-                <a:solidFill>
-                  <a:srgbClr val="2E6E9E"/>
+              <a:rPr sz="1200" b="1" i="0">
+                <a:solidFill>
+                  <a:srgbClr val="3D6A8E"/>
                 </a:solidFill>
                 <a:latin typeface="Calibri"/>
               </a:rPr>
@@ -23591,9 +23591,9 @@
             <a:r>
               <a:rPr sz="2700" b="1" i="0">
                 <a:solidFill>
-                  <a:srgbClr val="0E2A47"/>
-                </a:solidFill>
-                <a:latin typeface="Calibri"/>
+                  <a:srgbClr val="0B2A4A"/>
+                </a:solidFill>
+                <a:latin typeface="Georgia"/>
               </a:rPr>
               <a:t>L'IA : un levier de performance et un défi organisationnel</a:t>
             </a:r>
@@ -23615,7 +23615,7 @@
             <a:avLst/>
           </a:prstGeom>
           <a:solidFill>
-            <a:srgbClr val="E4A11B"/>
+            <a:srgbClr val="E6A339"/>
           </a:solidFill>
           <a:ln>
             <a:noFill/>
@@ -23665,7 +23665,7 @@
           </a:solidFill>
           <a:ln w="12700">
             <a:solidFill>
-              <a:srgbClr val="D7DDE6"/>
+              <a:srgbClr val="E6DFD3"/>
             </a:solidFill>
           </a:ln>
           <a:effectLst/>
@@ -23774,7 +23774,7 @@
                 <a:solidFill>
                   <a:srgbClr val="257448"/>
                 </a:solidFill>
-                <a:latin typeface="Calibri"/>
+                <a:latin typeface="Georgia"/>
               </a:rPr>
               <a:t>▲  OPPORTUNITÉS</a:t>
             </a:r>
@@ -23826,7 +23826,7 @@
             <a:r>
               <a:rPr sz="1350" b="1">
                 <a:solidFill>
-                  <a:srgbClr val="1A2033"/>
+                  <a:srgbClr val="18243C"/>
                 </a:solidFill>
                 <a:latin typeface="Calibri"/>
               </a:rPr>
@@ -23835,7 +23835,7 @@
             <a:r>
               <a:rPr sz="1350" b="0">
                 <a:solidFill>
-                  <a:srgbClr val="55607A"/>
+                  <a:srgbClr val="54607A"/>
                 </a:solidFill>
                 <a:latin typeface="Calibri"/>
               </a:rPr>
@@ -23866,7 +23866,7 @@
             <a:r>
               <a:rPr sz="1350" b="1">
                 <a:solidFill>
-                  <a:srgbClr val="1A2033"/>
+                  <a:srgbClr val="18243C"/>
                 </a:solidFill>
                 <a:latin typeface="Calibri"/>
               </a:rPr>
@@ -23875,7 +23875,7 @@
             <a:r>
               <a:rPr sz="1350" b="0">
                 <a:solidFill>
-                  <a:srgbClr val="55607A"/>
+                  <a:srgbClr val="54607A"/>
                 </a:solidFill>
                 <a:latin typeface="Calibri"/>
               </a:rPr>
@@ -23906,7 +23906,7 @@
             <a:r>
               <a:rPr sz="1350" b="1">
                 <a:solidFill>
-                  <a:srgbClr val="1A2033"/>
+                  <a:srgbClr val="18243C"/>
                 </a:solidFill>
                 <a:latin typeface="Calibri"/>
               </a:rPr>
@@ -23915,7 +23915,7 @@
             <a:r>
               <a:rPr sz="1350" b="0">
                 <a:solidFill>
-                  <a:srgbClr val="55607A"/>
+                  <a:srgbClr val="54607A"/>
                 </a:solidFill>
                 <a:latin typeface="Calibri"/>
               </a:rPr>
@@ -23945,7 +23945,7 @@
           </a:solidFill>
           <a:ln w="12700">
             <a:solidFill>
-              <a:srgbClr val="D7DDE6"/>
+              <a:srgbClr val="E6DFD3"/>
             </a:solidFill>
           </a:ln>
           <a:effectLst/>
@@ -24054,7 +24054,7 @@
                 <a:solidFill>
                   <a:srgbClr val="A84530"/>
                 </a:solidFill>
-                <a:latin typeface="Calibri"/>
+                <a:latin typeface="Georgia"/>
               </a:rPr>
               <a:t>▼  FREINS &amp; MENACES</a:t>
             </a:r>
@@ -24106,7 +24106,7 @@
             <a:r>
               <a:rPr sz="1350" b="1">
                 <a:solidFill>
-                  <a:srgbClr val="1A2033"/>
+                  <a:srgbClr val="18243C"/>
                 </a:solidFill>
                 <a:latin typeface="Calibri"/>
               </a:rPr>
@@ -24115,7 +24115,7 @@
             <a:r>
               <a:rPr sz="1350" b="0">
                 <a:solidFill>
-                  <a:srgbClr val="55607A"/>
+                  <a:srgbClr val="54607A"/>
                 </a:solidFill>
                 <a:latin typeface="Calibri"/>
               </a:rPr>
@@ -24146,7 +24146,7 @@
             <a:r>
               <a:rPr sz="1350" b="1">
                 <a:solidFill>
-                  <a:srgbClr val="1A2033"/>
+                  <a:srgbClr val="18243C"/>
                 </a:solidFill>
                 <a:latin typeface="Calibri"/>
               </a:rPr>
@@ -24155,7 +24155,7 @@
             <a:r>
               <a:rPr sz="1350" b="0">
                 <a:solidFill>
-                  <a:srgbClr val="55607A"/>
+                  <a:srgbClr val="54607A"/>
                 </a:solidFill>
                 <a:latin typeface="Calibri"/>
               </a:rPr>
@@ -24186,7 +24186,7 @@
             <a:r>
               <a:rPr sz="1350" b="1">
                 <a:solidFill>
-                  <a:srgbClr val="1A2033"/>
+                  <a:srgbClr val="18243C"/>
                 </a:solidFill>
                 <a:latin typeface="Calibri"/>
               </a:rPr>
@@ -24195,7 +24195,7 @@
             <a:r>
               <a:rPr sz="1350" b="0">
                 <a:solidFill>
-                  <a:srgbClr val="55607A"/>
+                  <a:srgbClr val="54607A"/>
                 </a:solidFill>
                 <a:latin typeface="Calibri"/>
               </a:rPr>
@@ -24219,7 +24219,7 @@
             <a:avLst/>
           </a:prstGeom>
           <a:solidFill>
-            <a:srgbClr val="F4F6F9"/>
+            <a:srgbClr val="EDF2F6"/>
           </a:solidFill>
           <a:ln>
             <a:noFill/>
@@ -24263,7 +24263,7 @@
             <a:avLst/>
           </a:prstGeom>
           <a:solidFill>
-            <a:srgbClr val="E4A11B"/>
+            <a:srgbClr val="E6A339"/>
           </a:solidFill>
           <a:ln>
             <a:noFill/>
@@ -24328,9 +24328,9 @@
             <a:r>
               <a:rPr sz="1250" b="1" i="0">
                 <a:solidFill>
-                  <a:srgbClr val="C6860E"/>
-                </a:solidFill>
-                <a:latin typeface="Calibri"/>
+                  <a:srgbClr val="AF7112"/>
+                </a:solidFill>
+                <a:latin typeface="Georgia"/>
               </a:rPr>
               <a:t>PROPOSITION 2</a:t>
             </a:r>
@@ -24373,7 +24373,7 @@
             <a:r>
               <a:rPr sz="1350" b="0" i="1">
                 <a:solidFill>
-                  <a:srgbClr val="1A2033"/>
+                  <a:srgbClr val="18243C"/>
                 </a:solidFill>
                 <a:latin typeface="Calibri"/>
               </a:rPr>
@@ -24505,7 +24505,7 @@
             <a:avLst/>
           </a:prstGeom>
           <a:solidFill>
-            <a:srgbClr val="FFFFFF"/>
+            <a:srgbClr val="FCFBF8"/>
           </a:solidFill>
           <a:ln>
             <a:noFill/>
@@ -24549,7 +24549,7 @@
             <a:avLst/>
           </a:prstGeom>
           <a:solidFill>
-            <a:srgbClr val="FFFFFF"/>
+            <a:srgbClr val="FCFBF8"/>
           </a:solidFill>
           <a:ln>
             <a:noFill/>
@@ -24593,7 +24593,7 @@
             <a:avLst/>
           </a:prstGeom>
           <a:solidFill>
-            <a:srgbClr val="E4A11B"/>
+            <a:srgbClr val="E6A339"/>
           </a:solidFill>
           <a:ln>
             <a:noFill/>
@@ -24656,9 +24656,9 @@
               </a:spcAft>
             </a:pPr>
             <a:r>
-              <a:rPr sz="1250" b="1" i="0">
-                <a:solidFill>
-                  <a:srgbClr val="2E6E9E"/>
+              <a:rPr sz="1200" b="1" i="0">
+                <a:solidFill>
+                  <a:srgbClr val="3D6A8E"/>
                 </a:solidFill>
                 <a:latin typeface="Calibri"/>
               </a:rPr>
@@ -24703,9 +24703,9 @@
             <a:r>
               <a:rPr sz="2700" b="1" i="0">
                 <a:solidFill>
-                  <a:srgbClr val="0E2A47"/>
-                </a:solidFill>
-                <a:latin typeface="Calibri"/>
+                  <a:srgbClr val="0B2A4A"/>
+                </a:solidFill>
+                <a:latin typeface="Georgia"/>
               </a:rPr>
               <a:t>De la théorie aux propositions de recherche</a:t>
             </a:r>
@@ -24727,7 +24727,7 @@
             <a:avLst/>
           </a:prstGeom>
           <a:solidFill>
-            <a:srgbClr val="E4A11B"/>
+            <a:srgbClr val="E6A339"/>
           </a:solidFill>
           <a:ln>
             <a:noFill/>
@@ -24792,9 +24792,9 @@
             <a:r>
               <a:rPr sz="1600" b="1" i="0">
                 <a:solidFill>
-                  <a:srgbClr val="0E2A47"/>
-                </a:solidFill>
-                <a:latin typeface="Calibri"/>
+                  <a:srgbClr val="0B2A4A"/>
+                </a:solidFill>
+                <a:latin typeface="Georgia"/>
               </a:rPr>
               <a:t>La PME face à l'IA : une double dynamique</a:t>
             </a:r>
@@ -24885,7 +24885,7 @@
                 <a:solidFill>
                   <a:srgbClr val="257448"/>
                 </a:solidFill>
-                <a:latin typeface="Calibri"/>
+                <a:latin typeface="Georgia"/>
               </a:rPr>
               <a:t>LEVIERS</a:t>
             </a:r>
@@ -24928,7 +24928,7 @@
             <a:r>
               <a:rPr sz="1350" b="0" i="0">
                 <a:solidFill>
-                  <a:srgbClr val="1A2033"/>
+                  <a:srgbClr val="18243C"/>
                 </a:solidFill>
                 <a:latin typeface="Calibri"/>
               </a:rPr>
@@ -25021,7 +25021,7 @@
                 <a:solidFill>
                   <a:srgbClr val="A84530"/>
                 </a:solidFill>
-                <a:latin typeface="Calibri"/>
+                <a:latin typeface="Georgia"/>
               </a:rPr>
               <a:t>FREINS</a:t>
             </a:r>
@@ -25064,7 +25064,7 @@
             <a:r>
               <a:rPr sz="1350" b="0" i="0">
                 <a:solidFill>
-                  <a:srgbClr val="1A2033"/>
+                  <a:srgbClr val="18243C"/>
                 </a:solidFill>
                 <a:latin typeface="Calibri"/>
               </a:rPr>
@@ -25109,9 +25109,9 @@
             <a:r>
               <a:rPr sz="1600" b="1" i="0">
                 <a:solidFill>
-                  <a:srgbClr val="0E2A47"/>
-                </a:solidFill>
-                <a:latin typeface="Calibri"/>
+                  <a:srgbClr val="0B2A4A"/>
+                </a:solidFill>
+                <a:latin typeface="Georgia"/>
               </a:rPr>
               <a:t>Trois propositions confrontées au terrain</a:t>
             </a:r>
@@ -25133,7 +25133,7 @@
             <a:avLst/>
           </a:prstGeom>
           <a:solidFill>
-            <a:srgbClr val="0E2A47"/>
+            <a:srgbClr val="0B2A4A"/>
           </a:solidFill>
           <a:ln>
             <a:noFill/>
@@ -25198,9 +25198,9 @@
             <a:r>
               <a:rPr sz="1400" b="1" i="0">
                 <a:solidFill>
-                  <a:srgbClr val="E4A11B"/>
-                </a:solidFill>
-                <a:latin typeface="Calibri"/>
+                  <a:srgbClr val="E6A339"/>
+                </a:solidFill>
+                <a:latin typeface="Georgia"/>
               </a:rPr>
               <a:t>QR1</a:t>
             </a:r>
@@ -25224,7 +25224,7 @@
             </a:avLst>
           </a:prstGeom>
           <a:solidFill>
-            <a:srgbClr val="F4F6F9"/>
+            <a:srgbClr val="EDF2F6"/>
           </a:solidFill>
           <a:ln>
             <a:noFill/>
@@ -25289,7 +25289,7 @@
             <a:r>
               <a:rPr sz="1350" b="0" i="0">
                 <a:solidFill>
-                  <a:srgbClr val="1A2033"/>
+                  <a:srgbClr val="18243C"/>
                 </a:solidFill>
                 <a:latin typeface="Calibri"/>
               </a:rPr>
@@ -25313,7 +25313,7 @@
             <a:avLst/>
           </a:prstGeom>
           <a:solidFill>
-            <a:srgbClr val="0E2A47"/>
+            <a:srgbClr val="0B2A4A"/>
           </a:solidFill>
           <a:ln>
             <a:noFill/>
@@ -25378,9 +25378,9 @@
             <a:r>
               <a:rPr sz="1400" b="1" i="0">
                 <a:solidFill>
-                  <a:srgbClr val="E4A11B"/>
-                </a:solidFill>
-                <a:latin typeface="Calibri"/>
+                  <a:srgbClr val="E6A339"/>
+                </a:solidFill>
+                <a:latin typeface="Georgia"/>
               </a:rPr>
               <a:t>QR2</a:t>
             </a:r>
@@ -25404,7 +25404,7 @@
             </a:avLst>
           </a:prstGeom>
           <a:solidFill>
-            <a:srgbClr val="F4F6F9"/>
+            <a:srgbClr val="EDF2F6"/>
           </a:solidFill>
           <a:ln>
             <a:noFill/>
@@ -25469,7 +25469,7 @@
             <a:r>
               <a:rPr sz="1350" b="0" i="0">
                 <a:solidFill>
-                  <a:srgbClr val="1A2033"/>
+                  <a:srgbClr val="18243C"/>
                 </a:solidFill>
                 <a:latin typeface="Calibri"/>
               </a:rPr>
@@ -25493,7 +25493,7 @@
             <a:avLst/>
           </a:prstGeom>
           <a:solidFill>
-            <a:srgbClr val="0E2A47"/>
+            <a:srgbClr val="0B2A4A"/>
           </a:solidFill>
           <a:ln>
             <a:noFill/>
@@ -25558,9 +25558,9 @@
             <a:r>
               <a:rPr sz="1400" b="1" i="0">
                 <a:solidFill>
-                  <a:srgbClr val="E4A11B"/>
-                </a:solidFill>
-                <a:latin typeface="Calibri"/>
+                  <a:srgbClr val="E6A339"/>
+                </a:solidFill>
+                <a:latin typeface="Georgia"/>
               </a:rPr>
               <a:t>QR3</a:t>
             </a:r>
@@ -25584,7 +25584,7 @@
             </a:avLst>
           </a:prstGeom>
           <a:solidFill>
-            <a:srgbClr val="F4F6F9"/>
+            <a:srgbClr val="EDF2F6"/>
           </a:solidFill>
           <a:ln>
             <a:noFill/>
@@ -25649,7 +25649,7 @@
             <a:r>
               <a:rPr sz="1350" b="0" i="0">
                 <a:solidFill>
-                  <a:srgbClr val="1A2033"/>
+                  <a:srgbClr val="18243C"/>
                 </a:solidFill>
                 <a:latin typeface="Calibri"/>
               </a:rPr>

</xml_diff>

<commit_message>
Ajoute une diapo de clôture « réalisé avec Claude » (mise en abyme)
22e diapositive de clôture, sur les versions web et PowerPoint : la
soutenance d'un mémoire portant sur l'intégration de l'IA a elle-même été
préparée avec l'IA. Cadrage assumé — l'IA comme outil d'appui, le travail
piloté, relu et assumé par son auteur (« l'IA assiste, l'humain décide »).

Co-Authored-By: Claude Opus 4.8 <noreply@anthropic.com>
Claude-Session: https://claude.ai/code/session_01B5VNFubZCPwHFVgGiYV1ZQ
</commit_message>
<xml_diff>
--- a/Soutenance_MFE_LOUSTALET_Maxime.pptx
+++ b/Soutenance_MFE_LOUSTALET_Maxime.pptx
@@ -26,6 +26,7 @@
     <p:sldId id="274" r:id="rId26"/>
     <p:sldId id="275" r:id="rId27"/>
     <p:sldId id="276" r:id="rId28"/>
+    <p:sldId id="277" r:id="rId29"/>
   </p:sldIdLst>
   <p:sldSz cx="12191695" cy="6858000" type="screen4x3"/>
   <p:notesSz cx="6858000" cy="9144000"/>
@@ -1667,6 +1668,82 @@
           <a:p>
             <a:r>
               <a:t>CONSEIL FINAL : marquez un temps d'arrêt, souriez, et laissez le jury ouvrir l'échange. Gardez en tête les questions probables : Pourquoi le qualitatif et pas le quantitatif ? Comment garantir l'objectivité avec 8 entretiens ? Vos préconisations sont-elles chiffrées / calendairisées ? Le ROI de l'IA pour Arla ? Le RGPD et la confidentialité des données chantier ? Comment gérez-vous votre propre position d'alternant (biais d'implication) ? Restez calme, reformulez la question, appuyez-vous sur vos verbatims.</a:t>
+            </a:r>
+          </a:p>
+        </p:txBody>
+      </p:sp>
+      <p:sp>
+        <p:nvSpPr>
+          <p:cNvPr id="4" name="Slide Number Placeholder 3"/>
+          <p:cNvSpPr>
+            <a:spLocks noGrp="1"/>
+          </p:cNvSpPr>
+          <p:nvPr>
+            <p:ph type="sldNum" idx="5" sz="quarter"/>
+          </p:nvPr>
+        </p:nvSpPr>
+        <p:spPr/>
+      </p:sp>
+    </p:spTree>
+  </p:cSld>
+  <p:clrMapOvr>
+    <a:masterClrMapping/>
+  </p:clrMapOvr>
+</p:notes>
+</file>
+
+<file path=ppt/notesSlides/notesSlide22.xml><?xml version="1.0" encoding="utf-8"?>
+<p:notes xmlns:a="http://schemas.openxmlformats.org/drawingml/2006/main" xmlns:p="http://schemas.openxmlformats.org/presentationml/2006/main" xmlns:r="http://schemas.openxmlformats.org/officeDocument/2006/relationships">
+  <p:cSld>
+    <p:spTree>
+      <p:nvGrpSpPr>
+        <p:cNvPr id="1" name=""/>
+        <p:cNvGrpSpPr/>
+        <p:nvPr/>
+      </p:nvGrpSpPr>
+      <p:grpSpPr>
+        <a:xfrm>
+          <a:off x="0" y="0"/>
+          <a:ext cx="0" cy="0"/>
+          <a:chOff x="0" y="0"/>
+          <a:chExt cx="0" cy="0"/>
+        </a:xfrm>
+      </p:grpSpPr>
+      <p:sp>
+        <p:nvSpPr>
+          <p:cNvPr id="2" name="Slide Image Placeholder 1"/>
+          <p:cNvSpPr>
+            <a:spLocks noGrp="1"/>
+          </p:cNvSpPr>
+          <p:nvPr>
+            <p:ph type="sldImg" idx="2"/>
+          </p:nvPr>
+        </p:nvSpPr>
+        <p:spPr/>
+      </p:sp>
+      <p:sp>
+        <p:nvSpPr>
+          <p:cNvPr id="3" name="Notes Placeholder 2"/>
+          <p:cNvSpPr>
+            <a:spLocks noGrp="1"/>
+          </p:cNvSpPr>
+          <p:nvPr>
+            <p:ph type="body" idx="3" sz="quarter"/>
+          </p:nvPr>
+        </p:nvSpPr>
+        <p:spPr/>
+        <p:txBody>
+          <a:bodyPr/>
+          <a:lstStyle/>
+          <a:p>
+            <a:r>
+              <a:t>[CLÔTURE ORIGINALE] Diapositive de clôture, à laisser affichée pendant les questions. C'est une mise en abyme assumée : ce mémoire porte sur l'intégration de l'IA, et sa soutenance a été préparée avec l'IA.</a:t>
+            </a:r>
+          </a:p>
+          <a:p/>
+          <a:p>
+            <a:r>
+              <a:t>Message à tenir si le jury en parle : l'IA a été un OUTIL d'appui — recherche, structuration, mise en forme — mais l'analyse, les choix et la rédaction restent les miens. « L'IA assiste, l'humain décide » : c'est exactement la posture d'usage raisonné que je défends dans mon mémoire. Terminer là-dessus montre une utilisation lucide, critique et transparente de l'outil.</a:t>
             </a:r>
           </a:p>
         </p:txBody>
@@ -18958,6 +19035,936 @@
                 <a:latin typeface="Calibri"/>
               </a:rPr>
               <a:t>Directeur de recherche : Victor COMBES   ·   Eklore-ed School of Management   ·   2025–2026</a:t>
+            </a:r>
+          </a:p>
+        </p:txBody>
+      </p:sp>
+    </p:spTree>
+  </p:cSld>
+  <p:clrMapOvr>
+    <a:masterClrMapping/>
+  </p:clrMapOvr>
+</p:sld>
+</file>
+
+<file path=ppt/slides/slide22.xml><?xml version="1.0" encoding="utf-8"?>
+<p:sld xmlns:a="http://schemas.openxmlformats.org/drawingml/2006/main" xmlns:p="http://schemas.openxmlformats.org/presentationml/2006/main" xmlns:r="http://schemas.openxmlformats.org/officeDocument/2006/relationships">
+  <p:cSld>
+    <p:spTree>
+      <p:nvGrpSpPr>
+        <p:cNvPr id="1" name=""/>
+        <p:cNvGrpSpPr/>
+        <p:nvPr/>
+      </p:nvGrpSpPr>
+      <p:grpSpPr/>
+      <p:sp>
+        <p:nvSpPr>
+          <p:cNvPr id="2" name="Rectangle 1"/>
+          <p:cNvSpPr/>
+          <p:nvPr/>
+        </p:nvSpPr>
+        <p:spPr>
+          <a:xfrm>
+            <a:off x="0" y="0"/>
+            <a:ext cx="12191695" cy="6858000"/>
+          </a:xfrm>
+          <a:prstGeom prst="rect">
+            <a:avLst/>
+          </a:prstGeom>
+          <a:solidFill>
+            <a:srgbClr val="0B2A4A"/>
+          </a:solidFill>
+          <a:ln>
+            <a:noFill/>
+          </a:ln>
+          <a:effectLst/>
+        </p:spPr>
+        <p:style>
+          <a:lnRef idx="1">
+            <a:schemeClr val="accent1"/>
+          </a:lnRef>
+          <a:fillRef idx="3">
+            <a:schemeClr val="accent1"/>
+          </a:fillRef>
+          <a:effectRef idx="2">
+            <a:schemeClr val="accent1"/>
+          </a:effectRef>
+          <a:fontRef idx="minor">
+            <a:schemeClr val="lt1"/>
+          </a:fontRef>
+        </p:style>
+        <p:txBody>
+          <a:bodyPr rtlCol="0" anchor="ctr"/>
+          <a:lstStyle/>
+          <a:p>
+            <a:pPr algn="ctr"/>
+          </a:p>
+        </p:txBody>
+      </p:sp>
+      <p:sp>
+        <p:nvSpPr>
+          <p:cNvPr id="3" name="Rectangle 2"/>
+          <p:cNvSpPr/>
+          <p:nvPr/>
+        </p:nvSpPr>
+        <p:spPr>
+          <a:xfrm>
+            <a:off x="0" y="0"/>
+            <a:ext cx="12191695" cy="256032"/>
+          </a:xfrm>
+          <a:prstGeom prst="rect">
+            <a:avLst/>
+          </a:prstGeom>
+          <a:solidFill>
+            <a:srgbClr val="E6A339"/>
+          </a:solidFill>
+          <a:ln>
+            <a:noFill/>
+          </a:ln>
+          <a:effectLst/>
+        </p:spPr>
+        <p:style>
+          <a:lnRef idx="1">
+            <a:schemeClr val="accent1"/>
+          </a:lnRef>
+          <a:fillRef idx="3">
+            <a:schemeClr val="accent1"/>
+          </a:fillRef>
+          <a:effectRef idx="2">
+            <a:schemeClr val="accent1"/>
+          </a:effectRef>
+          <a:fontRef idx="minor">
+            <a:schemeClr val="lt1"/>
+          </a:fontRef>
+        </p:style>
+        <p:txBody>
+          <a:bodyPr rtlCol="0" anchor="ctr"/>
+          <a:lstStyle/>
+          <a:p>
+            <a:pPr algn="ctr"/>
+          </a:p>
+        </p:txBody>
+      </p:sp>
+      <p:sp>
+        <p:nvSpPr>
+          <p:cNvPr id="4" name="Rectangle 3"/>
+          <p:cNvSpPr/>
+          <p:nvPr/>
+        </p:nvSpPr>
+        <p:spPr>
+          <a:xfrm>
+            <a:off x="0" y="6601968"/>
+            <a:ext cx="12191695" cy="256032"/>
+          </a:xfrm>
+          <a:prstGeom prst="rect">
+            <a:avLst/>
+          </a:prstGeom>
+          <a:solidFill>
+            <a:srgbClr val="E6A339"/>
+          </a:solidFill>
+          <a:ln>
+            <a:noFill/>
+          </a:ln>
+          <a:effectLst/>
+        </p:spPr>
+        <p:style>
+          <a:lnRef idx="1">
+            <a:schemeClr val="accent1"/>
+          </a:lnRef>
+          <a:fillRef idx="3">
+            <a:schemeClr val="accent1"/>
+          </a:fillRef>
+          <a:effectRef idx="2">
+            <a:schemeClr val="accent1"/>
+          </a:effectRef>
+          <a:fontRef idx="minor">
+            <a:schemeClr val="lt1"/>
+          </a:fontRef>
+        </p:style>
+        <p:txBody>
+          <a:bodyPr rtlCol="0" anchor="ctr"/>
+          <a:lstStyle/>
+          <a:p>
+            <a:pPr algn="ctr"/>
+          </a:p>
+        </p:txBody>
+      </p:sp>
+      <p:sp>
+        <p:nvSpPr>
+          <p:cNvPr id="5" name="Oval 4"/>
+          <p:cNvSpPr/>
+          <p:nvPr/>
+        </p:nvSpPr>
+        <p:spPr>
+          <a:xfrm>
+            <a:off x="8503920" y="914400"/>
+            <a:ext cx="2743200" cy="2743200"/>
+          </a:xfrm>
+          <a:prstGeom prst="ellipse">
+            <a:avLst/>
+          </a:prstGeom>
+          <a:noFill/>
+          <a:ln w="15875">
+            <a:solidFill>
+              <a:srgbClr val="24466B"/>
+            </a:solidFill>
+          </a:ln>
+          <a:effectLst/>
+        </p:spPr>
+        <p:style>
+          <a:lnRef idx="1">
+            <a:schemeClr val="accent1"/>
+          </a:lnRef>
+          <a:fillRef idx="3">
+            <a:schemeClr val="accent1"/>
+          </a:fillRef>
+          <a:effectRef idx="2">
+            <a:schemeClr val="accent1"/>
+          </a:effectRef>
+          <a:fontRef idx="minor">
+            <a:schemeClr val="lt1"/>
+          </a:fontRef>
+        </p:style>
+        <p:txBody>
+          <a:bodyPr rtlCol="0" anchor="ctr"/>
+          <a:lstStyle/>
+          <a:p>
+            <a:pPr algn="ctr"/>
+          </a:p>
+        </p:txBody>
+      </p:sp>
+      <p:sp>
+        <p:nvSpPr>
+          <p:cNvPr id="6" name="Oval 5"/>
+          <p:cNvSpPr/>
+          <p:nvPr/>
+        </p:nvSpPr>
+        <p:spPr>
+          <a:xfrm>
+            <a:off x="8915400" y="1325880"/>
+            <a:ext cx="1920240" cy="1920240"/>
+          </a:xfrm>
+          <a:prstGeom prst="ellipse">
+            <a:avLst/>
+          </a:prstGeom>
+          <a:noFill/>
+          <a:ln w="15875">
+            <a:solidFill>
+              <a:srgbClr val="24466B"/>
+            </a:solidFill>
+          </a:ln>
+          <a:effectLst/>
+        </p:spPr>
+        <p:style>
+          <a:lnRef idx="1">
+            <a:schemeClr val="accent1"/>
+          </a:lnRef>
+          <a:fillRef idx="3">
+            <a:schemeClr val="accent1"/>
+          </a:fillRef>
+          <a:effectRef idx="2">
+            <a:schemeClr val="accent1"/>
+          </a:effectRef>
+          <a:fontRef idx="minor">
+            <a:schemeClr val="lt1"/>
+          </a:fontRef>
+        </p:style>
+        <p:txBody>
+          <a:bodyPr rtlCol="0" anchor="ctr"/>
+          <a:lstStyle/>
+          <a:p>
+            <a:pPr algn="ctr"/>
+          </a:p>
+        </p:txBody>
+      </p:sp>
+      <p:sp>
+        <p:nvSpPr>
+          <p:cNvPr id="7" name="Oval 6"/>
+          <p:cNvSpPr/>
+          <p:nvPr/>
+        </p:nvSpPr>
+        <p:spPr>
+          <a:xfrm>
+            <a:off x="9308592" y="1719072"/>
+            <a:ext cx="1133856" cy="1133856"/>
+          </a:xfrm>
+          <a:prstGeom prst="ellipse">
+            <a:avLst/>
+          </a:prstGeom>
+          <a:noFill/>
+          <a:ln w="15875">
+            <a:solidFill>
+              <a:srgbClr val="24466B"/>
+            </a:solidFill>
+          </a:ln>
+          <a:effectLst/>
+        </p:spPr>
+        <p:style>
+          <a:lnRef idx="1">
+            <a:schemeClr val="accent1"/>
+          </a:lnRef>
+          <a:fillRef idx="3">
+            <a:schemeClr val="accent1"/>
+          </a:fillRef>
+          <a:effectRef idx="2">
+            <a:schemeClr val="accent1"/>
+          </a:effectRef>
+          <a:fontRef idx="minor">
+            <a:schemeClr val="lt1"/>
+          </a:fontRef>
+        </p:style>
+        <p:txBody>
+          <a:bodyPr rtlCol="0" anchor="ctr"/>
+          <a:lstStyle/>
+          <a:p>
+            <a:pPr algn="ctr"/>
+          </a:p>
+        </p:txBody>
+      </p:sp>
+      <p:sp>
+        <p:nvSpPr>
+          <p:cNvPr id="8" name="Diamond 7"/>
+          <p:cNvSpPr/>
+          <p:nvPr/>
+        </p:nvSpPr>
+        <p:spPr>
+          <a:xfrm>
+            <a:off x="9573768" y="1984248"/>
+            <a:ext cx="603504" cy="603504"/>
+          </a:xfrm>
+          <a:prstGeom prst="diamond">
+            <a:avLst/>
+          </a:prstGeom>
+          <a:solidFill>
+            <a:srgbClr val="E6A339"/>
+          </a:solidFill>
+          <a:ln>
+            <a:noFill/>
+          </a:ln>
+          <a:effectLst/>
+        </p:spPr>
+        <p:style>
+          <a:lnRef idx="1">
+            <a:schemeClr val="accent1"/>
+          </a:lnRef>
+          <a:fillRef idx="3">
+            <a:schemeClr val="accent1"/>
+          </a:fillRef>
+          <a:effectRef idx="2">
+            <a:schemeClr val="accent1"/>
+          </a:effectRef>
+          <a:fontRef idx="minor">
+            <a:schemeClr val="lt1"/>
+          </a:fontRef>
+        </p:style>
+        <p:txBody>
+          <a:bodyPr rtlCol="0" anchor="ctr"/>
+          <a:lstStyle/>
+          <a:p>
+            <a:pPr algn="ctr"/>
+          </a:p>
+        </p:txBody>
+      </p:sp>
+      <p:sp>
+        <p:nvSpPr>
+          <p:cNvPr id="9" name="Diamond 8"/>
+          <p:cNvSpPr/>
+          <p:nvPr/>
+        </p:nvSpPr>
+        <p:spPr>
+          <a:xfrm>
+            <a:off x="822960" y="1188720"/>
+            <a:ext cx="146304" cy="146304"/>
+          </a:xfrm>
+          <a:prstGeom prst="diamond">
+            <a:avLst/>
+          </a:prstGeom>
+          <a:solidFill>
+            <a:srgbClr val="E6A339"/>
+          </a:solidFill>
+          <a:ln>
+            <a:noFill/>
+          </a:ln>
+          <a:effectLst/>
+        </p:spPr>
+        <p:style>
+          <a:lnRef idx="1">
+            <a:schemeClr val="accent1"/>
+          </a:lnRef>
+          <a:fillRef idx="3">
+            <a:schemeClr val="accent1"/>
+          </a:fillRef>
+          <a:effectRef idx="2">
+            <a:schemeClr val="accent1"/>
+          </a:effectRef>
+          <a:fontRef idx="minor">
+            <a:schemeClr val="lt1"/>
+          </a:fontRef>
+        </p:style>
+        <p:txBody>
+          <a:bodyPr rtlCol="0" anchor="ctr"/>
+          <a:lstStyle/>
+          <a:p>
+            <a:pPr algn="ctr"/>
+          </a:p>
+        </p:txBody>
+      </p:sp>
+      <p:sp>
+        <p:nvSpPr>
+          <p:cNvPr id="10" name="TextBox 9"/>
+          <p:cNvSpPr txBox="1"/>
+          <p:nvPr/>
+        </p:nvSpPr>
+        <p:spPr>
+          <a:xfrm>
+            <a:off x="1097280" y="1088136"/>
+            <a:ext cx="8686800" cy="365760"/>
+          </a:xfrm>
+          <a:prstGeom prst="rect">
+            <a:avLst/>
+          </a:prstGeom>
+          <a:noFill/>
+        </p:spPr>
+        <p:txBody>
+          <a:bodyPr wrap="square" anchor="t" lIns="0" rIns="0" tIns="0" bIns="0">
+            <a:spAutoFit/>
+          </a:bodyPr>
+          <a:lstStyle/>
+          <a:p>
+            <a:pPr algn="l">
+              <a:lnSpc>
+                <a:spcPct val="100000"/>
+              </a:lnSpc>
+              <a:spcBef>
+                <a:spcPts val="0"/>
+              </a:spcBef>
+              <a:spcAft>
+                <a:spcPts val="0"/>
+              </a:spcAft>
+            </a:pPr>
+            <a:r>
+              <a:rPr sz="1250" b="1" i="0">
+                <a:solidFill>
+                  <a:srgbClr val="E6A339"/>
+                </a:solidFill>
+                <a:latin typeface="Calibri"/>
+              </a:rPr>
+              <a:t>MISE EN ABYME   ·   CLIN D'ŒIL FINAL</a:t>
+            </a:r>
+          </a:p>
+        </p:txBody>
+      </p:sp>
+      <p:sp>
+        <p:nvSpPr>
+          <p:cNvPr id="11" name="TextBox 10"/>
+          <p:cNvSpPr txBox="1"/>
+          <p:nvPr/>
+        </p:nvSpPr>
+        <p:spPr>
+          <a:xfrm>
+            <a:off x="822960" y="1737360"/>
+            <a:ext cx="8778240" cy="1554480"/>
+          </a:xfrm>
+          <a:prstGeom prst="rect">
+            <a:avLst/>
+          </a:prstGeom>
+          <a:noFill/>
+        </p:spPr>
+        <p:txBody>
+          <a:bodyPr wrap="square" anchor="t" lIns="0" rIns="0" tIns="0" bIns="0">
+            <a:spAutoFit/>
+          </a:bodyPr>
+          <a:lstStyle/>
+          <a:p>
+            <a:pPr algn="l">
+              <a:lnSpc>
+                <a:spcPct val="100000"/>
+              </a:lnSpc>
+              <a:spcBef>
+                <a:spcPts val="0"/>
+              </a:spcBef>
+              <a:spcAft>
+                <a:spcPts val="200"/>
+              </a:spcAft>
+            </a:pPr>
+            <a:r>
+              <a:rPr sz="3400" b="1" i="0">
+                <a:solidFill>
+                  <a:srgbClr val="FFFFFF"/>
+                </a:solidFill>
+                <a:latin typeface="Georgia"/>
+              </a:rPr>
+              <a:t>Réalisé avec Claude,</a:t>
+            </a:r>
+          </a:p>
+          <a:p>
+            <a:pPr algn="l">
+              <a:lnSpc>
+                <a:spcPct val="100000"/>
+              </a:lnSpc>
+              <a:spcBef>
+                <a:spcPts val="0"/>
+              </a:spcBef>
+              <a:spcAft>
+                <a:spcPts val="200"/>
+              </a:spcAft>
+            </a:pPr>
+            <a:r>
+              <a:rPr sz="3400" b="1" i="0">
+                <a:solidFill>
+                  <a:srgbClr val="FFFFFF"/>
+                </a:solidFill>
+                <a:latin typeface="Georgia"/>
+              </a:rPr>
+              <a:t>une intelligence artificielle</a:t>
+            </a:r>
+          </a:p>
+        </p:txBody>
+      </p:sp>
+      <p:sp>
+        <p:nvSpPr>
+          <p:cNvPr id="12" name="Rectangle 11"/>
+          <p:cNvSpPr/>
+          <p:nvPr/>
+        </p:nvSpPr>
+        <p:spPr>
+          <a:xfrm>
+            <a:off x="850392" y="3310128"/>
+            <a:ext cx="1371600" cy="45720"/>
+          </a:xfrm>
+          <a:prstGeom prst="rect">
+            <a:avLst/>
+          </a:prstGeom>
+          <a:solidFill>
+            <a:srgbClr val="E6A339"/>
+          </a:solidFill>
+          <a:ln>
+            <a:noFill/>
+          </a:ln>
+          <a:effectLst/>
+        </p:spPr>
+        <p:style>
+          <a:lnRef idx="1">
+            <a:schemeClr val="accent1"/>
+          </a:lnRef>
+          <a:fillRef idx="3">
+            <a:schemeClr val="accent1"/>
+          </a:fillRef>
+          <a:effectRef idx="2">
+            <a:schemeClr val="accent1"/>
+          </a:effectRef>
+          <a:fontRef idx="minor">
+            <a:schemeClr val="lt1"/>
+          </a:fontRef>
+        </p:style>
+        <p:txBody>
+          <a:bodyPr rtlCol="0" anchor="ctr"/>
+          <a:lstStyle/>
+          <a:p>
+            <a:pPr algn="ctr"/>
+          </a:p>
+        </p:txBody>
+      </p:sp>
+      <p:sp>
+        <p:nvSpPr>
+          <p:cNvPr id="13" name="TextBox 12"/>
+          <p:cNvSpPr txBox="1"/>
+          <p:nvPr/>
+        </p:nvSpPr>
+        <p:spPr>
+          <a:xfrm>
+            <a:off x="822960" y="3584448"/>
+            <a:ext cx="9601200" cy="731520"/>
+          </a:xfrm>
+          <a:prstGeom prst="rect">
+            <a:avLst/>
+          </a:prstGeom>
+          <a:noFill/>
+        </p:spPr>
+        <p:txBody>
+          <a:bodyPr wrap="square" anchor="t" lIns="0" rIns="0" tIns="0" bIns="0">
+            <a:spAutoFit/>
+          </a:bodyPr>
+          <a:lstStyle/>
+          <a:p>
+            <a:pPr algn="l">
+              <a:lnSpc>
+                <a:spcPct val="105000"/>
+              </a:lnSpc>
+              <a:spcBef>
+                <a:spcPts val="0"/>
+              </a:spcBef>
+              <a:spcAft>
+                <a:spcPts val="0"/>
+              </a:spcAft>
+            </a:pPr>
+            <a:r>
+              <a:rPr sz="1700" b="0" i="1">
+                <a:solidFill>
+                  <a:srgbClr val="D8E2EE"/>
+                </a:solidFill>
+                <a:latin typeface="Georgia"/>
+              </a:rPr>
+              <a:t>Le sujet de ce mémoire — l'intégration de l'IA — mis en pratique jusque dans sa soutenance.</a:t>
+            </a:r>
+          </a:p>
+        </p:txBody>
+      </p:sp>
+      <p:sp>
+        <p:nvSpPr>
+          <p:cNvPr id="14" name="TextBox 13"/>
+          <p:cNvSpPr txBox="1"/>
+          <p:nvPr/>
+        </p:nvSpPr>
+        <p:spPr>
+          <a:xfrm>
+            <a:off x="822960" y="4407408"/>
+            <a:ext cx="9966960" cy="914400"/>
+          </a:xfrm>
+          <a:prstGeom prst="rect">
+            <a:avLst/>
+          </a:prstGeom>
+          <a:noFill/>
+        </p:spPr>
+        <p:txBody>
+          <a:bodyPr wrap="square" anchor="t" lIns="0" rIns="0" tIns="0" bIns="0">
+            <a:spAutoFit/>
+          </a:bodyPr>
+          <a:lstStyle/>
+          <a:p>
+            <a:pPr algn="l">
+              <a:lnSpc>
+                <a:spcPct val="115000"/>
+              </a:lnSpc>
+              <a:spcBef>
+                <a:spcPts val="0"/>
+              </a:spcBef>
+              <a:spcAft>
+                <a:spcPts val="0"/>
+              </a:spcAft>
+            </a:pPr>
+            <a:r>
+              <a:rPr sz="1250" b="0" i="0">
+                <a:solidFill>
+                  <a:srgbClr val="93A6BD"/>
+                </a:solidFill>
+                <a:latin typeface="Calibri"/>
+              </a:rPr>
+              <a:t>L'intelligence artificielle y a servi d'outil d'appui — recherche documentaire, structuration et mise en forme — au service d'un travail pensé, piloté, relu et assumé par son auteur.</a:t>
+            </a:r>
+          </a:p>
+        </p:txBody>
+      </p:sp>
+      <p:sp>
+        <p:nvSpPr>
+          <p:cNvPr id="15" name="Rectangle 14"/>
+          <p:cNvSpPr/>
+          <p:nvPr/>
+        </p:nvSpPr>
+        <p:spPr>
+          <a:xfrm>
+            <a:off x="822960" y="5650992"/>
+            <a:ext cx="10515600" cy="18288"/>
+          </a:xfrm>
+          <a:prstGeom prst="rect">
+            <a:avLst/>
+          </a:prstGeom>
+          <a:solidFill>
+            <a:srgbClr val="2A476A"/>
+          </a:solidFill>
+          <a:ln>
+            <a:noFill/>
+          </a:ln>
+          <a:effectLst/>
+        </p:spPr>
+        <p:style>
+          <a:lnRef idx="1">
+            <a:schemeClr val="accent1"/>
+          </a:lnRef>
+          <a:fillRef idx="3">
+            <a:schemeClr val="accent1"/>
+          </a:fillRef>
+          <a:effectRef idx="2">
+            <a:schemeClr val="accent1"/>
+          </a:effectRef>
+          <a:fontRef idx="minor">
+            <a:schemeClr val="lt1"/>
+          </a:fontRef>
+        </p:style>
+        <p:txBody>
+          <a:bodyPr rtlCol="0" anchor="ctr"/>
+          <a:lstStyle/>
+          <a:p>
+            <a:pPr algn="ctr"/>
+          </a:p>
+        </p:txBody>
+      </p:sp>
+      <p:sp>
+        <p:nvSpPr>
+          <p:cNvPr id="16" name="TextBox 15"/>
+          <p:cNvSpPr txBox="1"/>
+          <p:nvPr/>
+        </p:nvSpPr>
+        <p:spPr>
+          <a:xfrm>
+            <a:off x="822960" y="5815584"/>
+            <a:ext cx="3291840" cy="274320"/>
+          </a:xfrm>
+          <a:prstGeom prst="rect">
+            <a:avLst/>
+          </a:prstGeom>
+          <a:noFill/>
+        </p:spPr>
+        <p:txBody>
+          <a:bodyPr wrap="square" anchor="t" lIns="0" rIns="0" tIns="0" bIns="0">
+            <a:spAutoFit/>
+          </a:bodyPr>
+          <a:lstStyle/>
+          <a:p>
+            <a:pPr algn="l">
+              <a:lnSpc>
+                <a:spcPct val="100000"/>
+              </a:lnSpc>
+              <a:spcBef>
+                <a:spcPts val="0"/>
+              </a:spcBef>
+              <a:spcAft>
+                <a:spcPts val="0"/>
+              </a:spcAft>
+            </a:pPr>
+            <a:r>
+              <a:rPr sz="950" b="1" i="0">
+                <a:solidFill>
+                  <a:srgbClr val="E6A339"/>
+                </a:solidFill>
+                <a:latin typeface="Calibri"/>
+              </a:rPr>
+              <a:t>AUTEUR</a:t>
+            </a:r>
+          </a:p>
+        </p:txBody>
+      </p:sp>
+      <p:sp>
+        <p:nvSpPr>
+          <p:cNvPr id="17" name="TextBox 16"/>
+          <p:cNvSpPr txBox="1"/>
+          <p:nvPr/>
+        </p:nvSpPr>
+        <p:spPr>
+          <a:xfrm>
+            <a:off x="822960" y="6062472"/>
+            <a:ext cx="3383280" cy="320040"/>
+          </a:xfrm>
+          <a:prstGeom prst="rect">
+            <a:avLst/>
+          </a:prstGeom>
+          <a:noFill/>
+        </p:spPr>
+        <p:txBody>
+          <a:bodyPr wrap="square" anchor="t" lIns="0" rIns="0" tIns="0" bIns="0">
+            <a:spAutoFit/>
+          </a:bodyPr>
+          <a:lstStyle/>
+          <a:p>
+            <a:pPr algn="l">
+              <a:lnSpc>
+                <a:spcPct val="100000"/>
+              </a:lnSpc>
+              <a:spcBef>
+                <a:spcPts val="0"/>
+              </a:spcBef>
+              <a:spcAft>
+                <a:spcPts val="0"/>
+              </a:spcAft>
+            </a:pPr>
+            <a:r>
+              <a:rPr sz="1250" b="1" i="0">
+                <a:solidFill>
+                  <a:srgbClr val="FFFFFF"/>
+                </a:solidFill>
+                <a:latin typeface="Calibri"/>
+              </a:rPr>
+              <a:t>Maxime LOUSTALET</a:t>
+            </a:r>
+          </a:p>
+        </p:txBody>
+      </p:sp>
+      <p:sp>
+        <p:nvSpPr>
+          <p:cNvPr id="18" name="TextBox 17"/>
+          <p:cNvSpPr txBox="1"/>
+          <p:nvPr/>
+        </p:nvSpPr>
+        <p:spPr>
+          <a:xfrm>
+            <a:off x="4251960" y="5815584"/>
+            <a:ext cx="3291840" cy="274320"/>
+          </a:xfrm>
+          <a:prstGeom prst="rect">
+            <a:avLst/>
+          </a:prstGeom>
+          <a:noFill/>
+        </p:spPr>
+        <p:txBody>
+          <a:bodyPr wrap="square" anchor="t" lIns="0" rIns="0" tIns="0" bIns="0">
+            <a:spAutoFit/>
+          </a:bodyPr>
+          <a:lstStyle/>
+          <a:p>
+            <a:pPr algn="l">
+              <a:lnSpc>
+                <a:spcPct val="100000"/>
+              </a:lnSpc>
+              <a:spcBef>
+                <a:spcPts val="0"/>
+              </a:spcBef>
+              <a:spcAft>
+                <a:spcPts val="0"/>
+              </a:spcAft>
+            </a:pPr>
+            <a:r>
+              <a:rPr sz="950" b="1" i="0">
+                <a:solidFill>
+                  <a:srgbClr val="E6A339"/>
+                </a:solidFill>
+                <a:latin typeface="Calibri"/>
+              </a:rPr>
+              <a:t>OUTIL D'APPUI</a:t>
+            </a:r>
+          </a:p>
+        </p:txBody>
+      </p:sp>
+      <p:sp>
+        <p:nvSpPr>
+          <p:cNvPr id="19" name="TextBox 18"/>
+          <p:cNvSpPr txBox="1"/>
+          <p:nvPr/>
+        </p:nvSpPr>
+        <p:spPr>
+          <a:xfrm>
+            <a:off x="4251960" y="6062472"/>
+            <a:ext cx="3383280" cy="320040"/>
+          </a:xfrm>
+          <a:prstGeom prst="rect">
+            <a:avLst/>
+          </a:prstGeom>
+          <a:noFill/>
+        </p:spPr>
+        <p:txBody>
+          <a:bodyPr wrap="square" anchor="t" lIns="0" rIns="0" tIns="0" bIns="0">
+            <a:spAutoFit/>
+          </a:bodyPr>
+          <a:lstStyle/>
+          <a:p>
+            <a:pPr algn="l">
+              <a:lnSpc>
+                <a:spcPct val="100000"/>
+              </a:lnSpc>
+              <a:spcBef>
+                <a:spcPts val="0"/>
+              </a:spcBef>
+              <a:spcAft>
+                <a:spcPts val="0"/>
+              </a:spcAft>
+            </a:pPr>
+            <a:r>
+              <a:rPr sz="1250" b="1" i="0">
+                <a:solidFill>
+                  <a:srgbClr val="FFFFFF"/>
+                </a:solidFill>
+                <a:latin typeface="Calibri"/>
+              </a:rPr>
+              <a:t>Claude — Anthropic</a:t>
+            </a:r>
+          </a:p>
+        </p:txBody>
+      </p:sp>
+      <p:sp>
+        <p:nvSpPr>
+          <p:cNvPr id="20" name="TextBox 19"/>
+          <p:cNvSpPr txBox="1"/>
+          <p:nvPr/>
+        </p:nvSpPr>
+        <p:spPr>
+          <a:xfrm>
+            <a:off x="7680960" y="5815584"/>
+            <a:ext cx="3291840" cy="274320"/>
+          </a:xfrm>
+          <a:prstGeom prst="rect">
+            <a:avLst/>
+          </a:prstGeom>
+          <a:noFill/>
+        </p:spPr>
+        <p:txBody>
+          <a:bodyPr wrap="square" anchor="t" lIns="0" rIns="0" tIns="0" bIns="0">
+            <a:spAutoFit/>
+          </a:bodyPr>
+          <a:lstStyle/>
+          <a:p>
+            <a:pPr algn="l">
+              <a:lnSpc>
+                <a:spcPct val="100000"/>
+              </a:lnSpc>
+              <a:spcBef>
+                <a:spcPts val="0"/>
+              </a:spcBef>
+              <a:spcAft>
+                <a:spcPts val="0"/>
+              </a:spcAft>
+            </a:pPr>
+            <a:r>
+              <a:rPr sz="950" b="1" i="0">
+                <a:solidFill>
+                  <a:srgbClr val="E6A339"/>
+                </a:solidFill>
+                <a:latin typeface="Calibri"/>
+              </a:rPr>
+              <a:t>PRINCIPE</a:t>
+            </a:r>
+          </a:p>
+        </p:txBody>
+      </p:sp>
+      <p:sp>
+        <p:nvSpPr>
+          <p:cNvPr id="21" name="TextBox 20"/>
+          <p:cNvSpPr txBox="1"/>
+          <p:nvPr/>
+        </p:nvSpPr>
+        <p:spPr>
+          <a:xfrm>
+            <a:off x="7680960" y="6062472"/>
+            <a:ext cx="3383280" cy="320040"/>
+          </a:xfrm>
+          <a:prstGeom prst="rect">
+            <a:avLst/>
+          </a:prstGeom>
+          <a:noFill/>
+        </p:spPr>
+        <p:txBody>
+          <a:bodyPr wrap="square" anchor="t" lIns="0" rIns="0" tIns="0" bIns="0">
+            <a:spAutoFit/>
+          </a:bodyPr>
+          <a:lstStyle/>
+          <a:p>
+            <a:pPr algn="l">
+              <a:lnSpc>
+                <a:spcPct val="100000"/>
+              </a:lnSpc>
+              <a:spcBef>
+                <a:spcPts val="0"/>
+              </a:spcBef>
+              <a:spcAft>
+                <a:spcPts val="0"/>
+              </a:spcAft>
+            </a:pPr>
+            <a:r>
+              <a:rPr sz="1250" b="1" i="0">
+                <a:solidFill>
+                  <a:srgbClr val="FFFFFF"/>
+                </a:solidFill>
+                <a:latin typeface="Calibri"/>
+              </a:rPr>
+              <a:t>L'IA assiste, l'humain décide</a:t>
             </a:r>
           </a:p>
         </p:txBody>

</xml_diff>